<commit_message>
Clarify Apple profile verification wording
</commit_message>
<xml_diff>
--- a/slides/london-office-monitoring.pptx
+++ b/slides/london-office-monitoring.pptx
@@ -2,17 +2,17 @@
 <file path=ppt/presentation.xml><?xml version="1.0" encoding="utf-8"?>
 <p:presentation xmlns:p="http://schemas.openxmlformats.org/presentationml/2006/main">
   <p:sldMasterIdLst>
-    <p:sldMasterId xmlns:r="http://schemas.openxmlformats.org/officeDocument/2006/relationships" id="2147483648" r:id="R2ab813856eca4fd2"/>
+    <p:sldMasterId xmlns:r="http://schemas.openxmlformats.org/officeDocument/2006/relationships" id="2147483648" r:id="R771c085644ee402f"/>
   </p:sldMasterIdLst>
   <p:notesMasterIdLst>
-    <p:notesMasterId xmlns:r="http://schemas.openxmlformats.org/officeDocument/2006/relationships" r:id="Rccb8054bb0ca444d"/>
+    <p:notesMasterId xmlns:r="http://schemas.openxmlformats.org/officeDocument/2006/relationships" r:id="R9dcf52f91b33405b"/>
   </p:notesMasterIdLst>
   <p:sldIdLst>
-    <p:sldId xmlns:r="http://schemas.openxmlformats.org/officeDocument/2006/relationships" id="256" r:id="R2537414b19d846f1"/>
-    <p:sldId xmlns:r="http://schemas.openxmlformats.org/officeDocument/2006/relationships" id="257" r:id="Rda866307c9ef45a9"/>
-    <p:sldId xmlns:r="http://schemas.openxmlformats.org/officeDocument/2006/relationships" id="258" r:id="Ree74268d73be46da"/>
-    <p:sldId xmlns:r="http://schemas.openxmlformats.org/officeDocument/2006/relationships" id="259" r:id="Rbce5e13236dc4f00"/>
-    <p:sldId xmlns:r="http://schemas.openxmlformats.org/officeDocument/2006/relationships" id="260" r:id="R52daf37cb603477d"/>
+    <p:sldId xmlns:r="http://schemas.openxmlformats.org/officeDocument/2006/relationships" id="256" r:id="R2fe287a8db794c0e"/>
+    <p:sldId xmlns:r="http://schemas.openxmlformats.org/officeDocument/2006/relationships" id="257" r:id="Rd5593be975794ab2"/>
+    <p:sldId xmlns:r="http://schemas.openxmlformats.org/officeDocument/2006/relationships" id="258" r:id="Ra3e8e2c8b2104e11"/>
+    <p:sldId xmlns:r="http://schemas.openxmlformats.org/officeDocument/2006/relationships" id="259" r:id="Rf606b12e52c74886"/>
+    <p:sldId xmlns:r="http://schemas.openxmlformats.org/officeDocument/2006/relationships" id="260" r:id="R294b8ea3384d44ea"/>
   </p:sldIdLst>
   <p:sldSz cx="12192000" cy="6858000"/>
   <p:notesSz cx="6858000" cy="9144000"/>
@@ -773,7 +773,7 @@
           <p:cNvPr id="3" name="Title">
             <a:extLst xmlns:a="http://schemas.openxmlformats.org/drawingml/2006/main">
               <a:ext uri="{FF2B5EF4-FFF2-40B4-BE49-F238E27FC236}">
-                <a16:creationId xmlns:a16="http://schemas.microsoft.com/office/drawing/2014/main" id="{29709C4B-37A5-4D09-8FE7-BADD2754C6CD}"/>
+                <a16:creationId xmlns:a16="http://schemas.microsoft.com/office/drawing/2014/main" id="{2792841E-D44C-4ECE-94AE-2E093663EB10}"/>
               </a:ext>
             </a:extLst>
           </p:cNvPr>
@@ -1002,7 +1002,7 @@
           <p:cNvPr id="2" name="Subtitle">
             <a:extLst xmlns:a="http://schemas.openxmlformats.org/drawingml/2006/main">
               <a:ext uri="{FF2B5EF4-FFF2-40B4-BE49-F238E27FC236}">
-                <a16:creationId xmlns:a16="http://schemas.microsoft.com/office/drawing/2014/main" id="{E9844512-CE8D-4EE1-9FE8-DAFA5A203FFD}"/>
+                <a16:creationId xmlns:a16="http://schemas.microsoft.com/office/drawing/2014/main" id="{4B7D9868-D706-454B-BACB-95812414B064}"/>
               </a:ext>
             </a:extLst>
           </p:cNvPr>
@@ -1248,7 +1248,7 @@
           <p:cNvPr id="2" name="Section title">
             <a:extLst xmlns:a="http://schemas.openxmlformats.org/drawingml/2006/main">
               <a:ext uri="{FF2B5EF4-FFF2-40B4-BE49-F238E27FC236}">
-                <a16:creationId xmlns:a16="http://schemas.microsoft.com/office/drawing/2014/main" id="{C8880966-DEAD-46A4-B514-9E029CAF7EFC}"/>
+                <a16:creationId xmlns:a16="http://schemas.microsoft.com/office/drawing/2014/main" id="{D50D1066-D559-4241-81C7-90C80AC97D0C}"/>
               </a:ext>
             </a:extLst>
           </p:cNvPr>
@@ -1494,7 +1494,7 @@
           <p:cNvPr id="3" name="Title">
             <a:extLst xmlns:a="http://schemas.openxmlformats.org/drawingml/2006/main">
               <a:ext uri="{FF2B5EF4-FFF2-40B4-BE49-F238E27FC236}">
-                <a16:creationId xmlns:a16="http://schemas.microsoft.com/office/drawing/2014/main" id="{E432EDE8-A0AA-4DD6-95CB-671D77487E38}"/>
+                <a16:creationId xmlns:a16="http://schemas.microsoft.com/office/drawing/2014/main" id="{861B6AB9-B1DC-4219-92AA-B9CF7518BAEF}"/>
               </a:ext>
             </a:extLst>
           </p:cNvPr>
@@ -1723,7 +1723,7 @@
           <p:cNvPr id="2" name="Body">
             <a:extLst xmlns:a="http://schemas.openxmlformats.org/drawingml/2006/main">
               <a:ext uri="{FF2B5EF4-FFF2-40B4-BE49-F238E27FC236}">
-                <a16:creationId xmlns:a16="http://schemas.microsoft.com/office/drawing/2014/main" id="{38E40463-C811-45B2-9797-5881980D7E46}"/>
+                <a16:creationId xmlns:a16="http://schemas.microsoft.com/office/drawing/2014/main" id="{6172BBE9-E6A5-497A-A325-5E69029773A9}"/>
               </a:ext>
             </a:extLst>
           </p:cNvPr>
@@ -1969,7 +1969,7 @@
           <p:cNvPr id="4" name="Title">
             <a:extLst xmlns:a="http://schemas.openxmlformats.org/drawingml/2006/main">
               <a:ext uri="{FF2B5EF4-FFF2-40B4-BE49-F238E27FC236}">
-                <a16:creationId xmlns:a16="http://schemas.microsoft.com/office/drawing/2014/main" id="{4B62045C-8791-4BBF-81F8-84FC220F91C9}"/>
+                <a16:creationId xmlns:a16="http://schemas.microsoft.com/office/drawing/2014/main" id="{99C2A397-3B23-4621-86D6-AA867802CFEB}"/>
               </a:ext>
             </a:extLst>
           </p:cNvPr>
@@ -2198,7 +2198,7 @@
           <p:cNvPr id="2" name="Left column">
             <a:extLst xmlns:a="http://schemas.openxmlformats.org/drawingml/2006/main">
               <a:ext uri="{FF2B5EF4-FFF2-40B4-BE49-F238E27FC236}">
-                <a16:creationId xmlns:a16="http://schemas.microsoft.com/office/drawing/2014/main" id="{BA2667FB-D696-4E9A-9978-BB6A893B10A8}"/>
+                <a16:creationId xmlns:a16="http://schemas.microsoft.com/office/drawing/2014/main" id="{D82E0304-342B-4489-9D28-66F71D4A84DA}"/>
               </a:ext>
             </a:extLst>
           </p:cNvPr>
@@ -2427,7 +2427,7 @@
           <p:cNvPr id="3" name="Right column">
             <a:extLst xmlns:a="http://schemas.openxmlformats.org/drawingml/2006/main">
               <a:ext uri="{FF2B5EF4-FFF2-40B4-BE49-F238E27FC236}">
-                <a16:creationId xmlns:a16="http://schemas.microsoft.com/office/drawing/2014/main" id="{82418F80-6F52-4911-8277-FF3058C3ABC8}"/>
+                <a16:creationId xmlns:a16="http://schemas.microsoft.com/office/drawing/2014/main" id="{12BA8364-D640-4912-A31A-1CC3EDB79D3E}"/>
               </a:ext>
             </a:extLst>
           </p:cNvPr>
@@ -2673,7 +2673,7 @@
           <p:cNvPr id="3" name="Title">
             <a:extLst xmlns:a="http://schemas.openxmlformats.org/drawingml/2006/main">
               <a:ext uri="{FF2B5EF4-FFF2-40B4-BE49-F238E27FC236}">
-                <a16:creationId xmlns:a16="http://schemas.microsoft.com/office/drawing/2014/main" id="{16084536-D20B-42CD-ADF4-721407AE6C5F}"/>
+                <a16:creationId xmlns:a16="http://schemas.microsoft.com/office/drawing/2014/main" id="{029978CC-92F8-44A7-BD8D-2D089CF8027A}"/>
               </a:ext>
             </a:extLst>
           </p:cNvPr>
@@ -2902,7 +2902,7 @@
           <p:cNvPr id="2" name="Left column">
             <a:extLst xmlns:a="http://schemas.openxmlformats.org/drawingml/2006/main">
               <a:ext uri="{FF2B5EF4-FFF2-40B4-BE49-F238E27FC236}">
-                <a16:creationId xmlns:a16="http://schemas.microsoft.com/office/drawing/2014/main" id="{AA1A20A7-BDF3-4D61-8A82-391AC30E1682}"/>
+                <a16:creationId xmlns:a16="http://schemas.microsoft.com/office/drawing/2014/main" id="{908AD3AB-923B-4B1C-9D7B-A1E291C68AE6}"/>
               </a:ext>
             </a:extLst>
           </p:cNvPr>
@@ -3169,12 +3169,12 @@
   </p:cSld>
   <p:clrMap bg1="lt1" tx1="dk1" bg2="lt2" tx2="dk2" accent1="accent1" accent2="accent2" accent3="accent3" accent4="accent4" accent5="accent5" accent6="accent6" hlink="hlink" folHlink="folHlink"/>
   <p:sldLayoutIdLst>
-    <p:sldLayoutId xmlns:r="http://schemas.openxmlformats.org/officeDocument/2006/relationships" id="2147483649" r:id="Recb701d124fc425f"/>
-    <p:sldLayoutId xmlns:r="http://schemas.openxmlformats.org/officeDocument/2006/relationships" id="2147483650" r:id="R1a960eead1d14680"/>
-    <p:sldLayoutId xmlns:r="http://schemas.openxmlformats.org/officeDocument/2006/relationships" id="2147483651" r:id="R0edddf76a5dc4811"/>
-    <p:sldLayoutId xmlns:r="http://schemas.openxmlformats.org/officeDocument/2006/relationships" id="2147483652" r:id="R41e4577f7f174abc"/>
-    <p:sldLayoutId xmlns:r="http://schemas.openxmlformats.org/officeDocument/2006/relationships" id="2147483653" r:id="R83e5ff37335f42db"/>
-    <p:sldLayoutId xmlns:r="http://schemas.openxmlformats.org/officeDocument/2006/relationships" id="2147483654" r:id="Rd28223013b914378"/>
+    <p:sldLayoutId xmlns:r="http://schemas.openxmlformats.org/officeDocument/2006/relationships" id="2147483649" r:id="R1c45517378b34800"/>
+    <p:sldLayoutId xmlns:r="http://schemas.openxmlformats.org/officeDocument/2006/relationships" id="2147483650" r:id="R098e7c72005f4a1c"/>
+    <p:sldLayoutId xmlns:r="http://schemas.openxmlformats.org/officeDocument/2006/relationships" id="2147483651" r:id="R84b6eebb501645b0"/>
+    <p:sldLayoutId xmlns:r="http://schemas.openxmlformats.org/officeDocument/2006/relationships" id="2147483652" r:id="R2607d1c471bc48a9"/>
+    <p:sldLayoutId xmlns:r="http://schemas.openxmlformats.org/officeDocument/2006/relationships" id="2147483653" r:id="R5136003263514ee2"/>
+    <p:sldLayoutId xmlns:r="http://schemas.openxmlformats.org/officeDocument/2006/relationships" id="2147483654" r:id="Rf94b156f45084ac5"/>
   </p:sldLayoutIdLst>
   <p:txStyles>
     <p:titleStyle>
@@ -3725,7 +3725,7 @@
           <p:cNvPr id="9" name="">
             <a:extLst xmlns:a="http://schemas.openxmlformats.org/drawingml/2006/main">
               <a:ext uri="{FF2B5EF4-FFF2-40B4-BE49-F238E27FC236}">
-                <a16:creationId xmlns:a16="http://schemas.microsoft.com/office/drawing/2014/main" id="{6EFBB752-A01E-4AED-878E-C0171463BC17}"/>
+                <a16:creationId xmlns:a16="http://schemas.microsoft.com/office/drawing/2014/main" id="{CA1D682F-C22C-4E92-9ABE-F0DBB2E5B752}"/>
               </a:ext>
             </a:extLst>
           </p:cNvPr>
@@ -3881,7 +3881,7 @@
           <p:cNvPr id="2" name="">
             <a:extLst xmlns:a="http://schemas.openxmlformats.org/drawingml/2006/main">
               <a:ext uri="{FF2B5EF4-FFF2-40B4-BE49-F238E27FC236}">
-                <a16:creationId xmlns:a16="http://schemas.microsoft.com/office/drawing/2014/main" id="{0AF64059-717B-4C95-B5A7-DB6D8617964C}"/>
+                <a16:creationId xmlns:a16="http://schemas.microsoft.com/office/drawing/2014/main" id="{3E754495-954B-4C5F-A4AC-D167C5FCEECC}"/>
               </a:ext>
             </a:extLst>
           </p:cNvPr>
@@ -4037,7 +4037,7 @@
           <p:cNvPr id="3" name="">
             <a:extLst xmlns:a="http://schemas.openxmlformats.org/drawingml/2006/main">
               <a:ext uri="{FF2B5EF4-FFF2-40B4-BE49-F238E27FC236}">
-                <a16:creationId xmlns:a16="http://schemas.microsoft.com/office/drawing/2014/main" id="{ECA76207-25CF-49BE-8B33-DDBEAABC2B3F}"/>
+                <a16:creationId xmlns:a16="http://schemas.microsoft.com/office/drawing/2014/main" id="{0E7B6CF8-F400-4A44-BFA5-087EFE81B45B}"/>
               </a:ext>
             </a:extLst>
           </p:cNvPr>
@@ -4193,7 +4193,7 @@
           <p:cNvPr id="4" name="">
             <a:extLst xmlns:a="http://schemas.openxmlformats.org/drawingml/2006/main">
               <a:ext uri="{FF2B5EF4-FFF2-40B4-BE49-F238E27FC236}">
-                <a16:creationId xmlns:a16="http://schemas.microsoft.com/office/drawing/2014/main" id="{2A7A7D34-A0F2-49F5-8876-B342BE787EF5}"/>
+                <a16:creationId xmlns:a16="http://schemas.microsoft.com/office/drawing/2014/main" id="{3414E401-C809-4C96-9560-1F36809F7FAF}"/>
               </a:ext>
             </a:extLst>
           </p:cNvPr>
@@ -4372,7 +4372,7 @@
           <p:cNvPr id="5" name="">
             <a:extLst xmlns:a="http://schemas.openxmlformats.org/drawingml/2006/main">
               <a:ext uri="{FF2B5EF4-FFF2-40B4-BE49-F238E27FC236}">
-                <a16:creationId xmlns:a16="http://schemas.microsoft.com/office/drawing/2014/main" id="{7427E7CB-483D-478A-8C85-59C0A1AF509F}"/>
+                <a16:creationId xmlns:a16="http://schemas.microsoft.com/office/drawing/2014/main" id="{92CB56DB-34BC-4C34-AD4A-84DAFC8CECAD}"/>
               </a:ext>
             </a:extLst>
           </p:cNvPr>
@@ -4551,7 +4551,7 @@
           <p:cNvPr id="6" name="">
             <a:extLst xmlns:a="http://schemas.openxmlformats.org/drawingml/2006/main">
               <a:ext uri="{FF2B5EF4-FFF2-40B4-BE49-F238E27FC236}">
-                <a16:creationId xmlns:a16="http://schemas.microsoft.com/office/drawing/2014/main" id="{097E35C0-9DA9-41EE-A147-F172B8244803}"/>
+                <a16:creationId xmlns:a16="http://schemas.microsoft.com/office/drawing/2014/main" id="{3D7B09C9-0D78-4205-92D8-1A7D3BD0288A}"/>
               </a:ext>
             </a:extLst>
           </p:cNvPr>
@@ -4707,7 +4707,7 @@
           <p:cNvPr id="7" name="">
             <a:extLst xmlns:a="http://schemas.openxmlformats.org/drawingml/2006/main">
               <a:ext uri="{FF2B5EF4-FFF2-40B4-BE49-F238E27FC236}">
-                <a16:creationId xmlns:a16="http://schemas.microsoft.com/office/drawing/2014/main" id="{9D2020E8-37F7-497D-AEC4-FC6F9072E460}"/>
+                <a16:creationId xmlns:a16="http://schemas.microsoft.com/office/drawing/2014/main" id="{16CAF14E-DAC6-4459-9393-EE2DCB95997E}"/>
               </a:ext>
             </a:extLst>
           </p:cNvPr>
@@ -4863,7 +4863,7 @@
           <p:cNvPr id="8" name="">
             <a:extLst xmlns:a="http://schemas.openxmlformats.org/drawingml/2006/main">
               <a:ext uri="{FF2B5EF4-FFF2-40B4-BE49-F238E27FC236}">
-                <a16:creationId xmlns:a16="http://schemas.microsoft.com/office/drawing/2014/main" id="{DE2521F9-818C-44A6-B6A6-13D158DBC3FD}"/>
+                <a16:creationId xmlns:a16="http://schemas.microsoft.com/office/drawing/2014/main" id="{F59CD43D-50AB-41D9-A022-48E9308A577A}"/>
               </a:ext>
             </a:extLst>
           </p:cNvPr>
@@ -5017,7 +5017,7 @@
     </p:spTree>
     <p:extLst>
       <p:ext uri="{BB962C8B-B14F-4D97-AF65-F5344CB8AC3E}">
-        <p14:creationId xmlns:p14="http://schemas.microsoft.com/office/powerpoint/2010/main" val="675013335"/>
+        <p14:creationId xmlns:p14="http://schemas.microsoft.com/office/powerpoint/2010/main" val="1759581918"/>
       </p:ext>
     </p:extLst>
   </p:cSld>
@@ -5048,7 +5048,7 @@
           <p:cNvPr id="22" name="">
             <a:extLst xmlns:a="http://schemas.openxmlformats.org/drawingml/2006/main">
               <a:ext uri="{FF2B5EF4-FFF2-40B4-BE49-F238E27FC236}">
-                <a16:creationId xmlns:a16="http://schemas.microsoft.com/office/drawing/2014/main" id="{41D2174C-16BD-47D3-A43F-3F1E4ED4C166}"/>
+                <a16:creationId xmlns:a16="http://schemas.microsoft.com/office/drawing/2014/main" id="{ECA53BF9-8D92-4929-A717-395589A6A19F}"/>
               </a:ext>
             </a:extLst>
           </p:cNvPr>
@@ -5080,7 +5080,7 @@
           <p:cNvPr id="18" name="">
             <a:extLst xmlns:a="http://schemas.openxmlformats.org/drawingml/2006/main">
               <a:ext uri="{FF2B5EF4-FFF2-40B4-BE49-F238E27FC236}">
-                <a16:creationId xmlns:a16="http://schemas.microsoft.com/office/drawing/2014/main" id="{77F6217A-9DB3-43A4-8453-34E31856E538}"/>
+                <a16:creationId xmlns:a16="http://schemas.microsoft.com/office/drawing/2014/main" id="{36BB6BEC-51D4-4948-9004-748CA3DB2181}"/>
               </a:ext>
             </a:extLst>
           </p:cNvPr>
@@ -5114,7 +5114,7 @@
           <p:cNvPr id="17" name="">
             <a:extLst xmlns:a="http://schemas.openxmlformats.org/drawingml/2006/main">
               <a:ext uri="{FF2B5EF4-FFF2-40B4-BE49-F238E27FC236}">
-                <a16:creationId xmlns:a16="http://schemas.microsoft.com/office/drawing/2014/main" id="{D7E1C9A4-A6F5-4BD6-A590-6A5CB17187AB}"/>
+                <a16:creationId xmlns:a16="http://schemas.microsoft.com/office/drawing/2014/main" id="{9897A66D-82FB-4340-8D61-22443A1A4838}"/>
               </a:ext>
             </a:extLst>
           </p:cNvPr>
@@ -5146,7 +5146,7 @@
           <p:cNvPr id="16" name="">
             <a:extLst xmlns:a="http://schemas.openxmlformats.org/drawingml/2006/main">
               <a:ext uri="{FF2B5EF4-FFF2-40B4-BE49-F238E27FC236}">
-                <a16:creationId xmlns:a16="http://schemas.microsoft.com/office/drawing/2014/main" id="{6067C293-A9AF-4AB2-A114-7C1C8BEC78E6}"/>
+                <a16:creationId xmlns:a16="http://schemas.microsoft.com/office/drawing/2014/main" id="{7789D711-E23F-4E2D-8633-B7B11A67E314}"/>
               </a:ext>
             </a:extLst>
           </p:cNvPr>
@@ -5178,7 +5178,7 @@
           <p:cNvPr id="26" name="">
             <a:extLst xmlns:a="http://schemas.openxmlformats.org/drawingml/2006/main">
               <a:ext uri="{FF2B5EF4-FFF2-40B4-BE49-F238E27FC236}">
-                <a16:creationId xmlns:a16="http://schemas.microsoft.com/office/drawing/2014/main" id="{B2433B46-CF8C-468A-B425-F2116064B721}"/>
+                <a16:creationId xmlns:a16="http://schemas.microsoft.com/office/drawing/2014/main" id="{DE262BE3-1972-4ACD-99A8-153961BF3789}"/>
               </a:ext>
             </a:extLst>
           </p:cNvPr>
@@ -5334,7 +5334,7 @@
           <p:cNvPr id="2" name="">
             <a:extLst xmlns:a="http://schemas.openxmlformats.org/drawingml/2006/main">
               <a:ext uri="{FF2B5EF4-FFF2-40B4-BE49-F238E27FC236}">
-                <a16:creationId xmlns:a16="http://schemas.microsoft.com/office/drawing/2014/main" id="{CDDAEF73-FCD3-4BE3-A323-734FFEDA1F18}"/>
+                <a16:creationId xmlns:a16="http://schemas.microsoft.com/office/drawing/2014/main" id="{D1C2406C-097D-442D-AF99-4AD1DF2D4EE3}"/>
               </a:ext>
             </a:extLst>
           </p:cNvPr>
@@ -5490,7 +5490,7 @@
           <p:cNvPr id="3" name="">
             <a:extLst xmlns:a="http://schemas.openxmlformats.org/drawingml/2006/main">
               <a:ext uri="{FF2B5EF4-FFF2-40B4-BE49-F238E27FC236}">
-                <a16:creationId xmlns:a16="http://schemas.microsoft.com/office/drawing/2014/main" id="{7C0AB53A-5067-466E-A653-8C6C5BCFE709}"/>
+                <a16:creationId xmlns:a16="http://schemas.microsoft.com/office/drawing/2014/main" id="{D38FAE97-96DC-46D2-B1EF-5B9379275078}"/>
               </a:ext>
             </a:extLst>
           </p:cNvPr>
@@ -5646,7 +5646,7 @@
           <p:cNvPr id="4" name="">
             <a:extLst xmlns:a="http://schemas.openxmlformats.org/drawingml/2006/main">
               <a:ext uri="{FF2B5EF4-FFF2-40B4-BE49-F238E27FC236}">
-                <a16:creationId xmlns:a16="http://schemas.microsoft.com/office/drawing/2014/main" id="{5E2151C0-32AC-45C0-AC19-FF2A3ACF701E}"/>
+                <a16:creationId xmlns:a16="http://schemas.microsoft.com/office/drawing/2014/main" id="{B79D90A5-B9FB-4510-BDA5-6445FAEE0B47}"/>
               </a:ext>
             </a:extLst>
           </p:cNvPr>
@@ -5802,7 +5802,7 @@
           <p:cNvPr id="5" name="">
             <a:extLst xmlns:a="http://schemas.openxmlformats.org/drawingml/2006/main">
               <a:ext uri="{FF2B5EF4-FFF2-40B4-BE49-F238E27FC236}">
-                <a16:creationId xmlns:a16="http://schemas.microsoft.com/office/drawing/2014/main" id="{24C2F933-1505-41A7-BA20-095C6797EB92}"/>
+                <a16:creationId xmlns:a16="http://schemas.microsoft.com/office/drawing/2014/main" id="{09B562AC-2D48-4C7B-B262-73ACB9B08221}"/>
               </a:ext>
             </a:extLst>
           </p:cNvPr>
@@ -5958,7 +5958,7 @@
           <p:cNvPr id="6" name="">
             <a:extLst xmlns:a="http://schemas.openxmlformats.org/drawingml/2006/main">
               <a:ext uri="{FF2B5EF4-FFF2-40B4-BE49-F238E27FC236}">
-                <a16:creationId xmlns:a16="http://schemas.microsoft.com/office/drawing/2014/main" id="{1C42B81F-CEE7-49F8-910E-BBA149D1C5E9}"/>
+                <a16:creationId xmlns:a16="http://schemas.microsoft.com/office/drawing/2014/main" id="{7A9C516B-9F84-40F2-A4DC-38798E192D95}"/>
               </a:ext>
             </a:extLst>
           </p:cNvPr>
@@ -5990,7 +5990,7 @@
           <p:cNvPr id="7" name="">
             <a:extLst xmlns:a="http://schemas.openxmlformats.org/drawingml/2006/main">
               <a:ext uri="{FF2B5EF4-FFF2-40B4-BE49-F238E27FC236}">
-                <a16:creationId xmlns:a16="http://schemas.microsoft.com/office/drawing/2014/main" id="{0901B8C2-E491-48C9-9D02-55CB70A8285E}"/>
+                <a16:creationId xmlns:a16="http://schemas.microsoft.com/office/drawing/2014/main" id="{7EB23403-AEA5-4619-B5E9-B9789DC53316}"/>
               </a:ext>
             </a:extLst>
           </p:cNvPr>
@@ -6169,7 +6169,7 @@
           <p:cNvPr id="8" name="">
             <a:extLst xmlns:a="http://schemas.openxmlformats.org/drawingml/2006/main">
               <a:ext uri="{FF2B5EF4-FFF2-40B4-BE49-F238E27FC236}">
-                <a16:creationId xmlns:a16="http://schemas.microsoft.com/office/drawing/2014/main" id="{90486B2A-F98D-41AB-B51A-DE5DAF1390AA}"/>
+                <a16:creationId xmlns:a16="http://schemas.microsoft.com/office/drawing/2014/main" id="{DC92F593-AA1E-454B-94D6-8F7A31C5BC18}"/>
               </a:ext>
             </a:extLst>
           </p:cNvPr>
@@ -6201,7 +6201,7 @@
           <p:cNvPr id="9" name="">
             <a:extLst xmlns:a="http://schemas.openxmlformats.org/drawingml/2006/main">
               <a:ext uri="{FF2B5EF4-FFF2-40B4-BE49-F238E27FC236}">
-                <a16:creationId xmlns:a16="http://schemas.microsoft.com/office/drawing/2014/main" id="{CA959047-1967-4BCC-AEEA-23F9E2B7F25E}"/>
+                <a16:creationId xmlns:a16="http://schemas.microsoft.com/office/drawing/2014/main" id="{FE7B0F7D-8E84-4D41-B637-CF28E35320C1}"/>
               </a:ext>
             </a:extLst>
           </p:cNvPr>
@@ -6380,7 +6380,7 @@
           <p:cNvPr id="10" name="">
             <a:extLst xmlns:a="http://schemas.openxmlformats.org/drawingml/2006/main">
               <a:ext uri="{FF2B5EF4-FFF2-40B4-BE49-F238E27FC236}">
-                <a16:creationId xmlns:a16="http://schemas.microsoft.com/office/drawing/2014/main" id="{AA6A6C47-B4AA-487F-9B1A-5534FFCC8BCB}"/>
+                <a16:creationId xmlns:a16="http://schemas.microsoft.com/office/drawing/2014/main" id="{3A1999F1-FC59-4FC7-9400-196907B86737}"/>
               </a:ext>
             </a:extLst>
           </p:cNvPr>
@@ -6412,7 +6412,7 @@
           <p:cNvPr id="11" name="">
             <a:extLst xmlns:a="http://schemas.openxmlformats.org/drawingml/2006/main">
               <a:ext uri="{FF2B5EF4-FFF2-40B4-BE49-F238E27FC236}">
-                <a16:creationId xmlns:a16="http://schemas.microsoft.com/office/drawing/2014/main" id="{684FE990-472A-49BE-8334-D849143FA164}"/>
+                <a16:creationId xmlns:a16="http://schemas.microsoft.com/office/drawing/2014/main" id="{18162CE4-CFB8-45F3-A1E8-386A9ACE4874}"/>
               </a:ext>
             </a:extLst>
           </p:cNvPr>
@@ -6591,7 +6591,7 @@
           <p:cNvPr id="12" name="">
             <a:extLst xmlns:a="http://schemas.openxmlformats.org/drawingml/2006/main">
               <a:ext uri="{FF2B5EF4-FFF2-40B4-BE49-F238E27FC236}">
-                <a16:creationId xmlns:a16="http://schemas.microsoft.com/office/drawing/2014/main" id="{AE771EAB-71A4-454C-800E-28C0C4163C06}"/>
+                <a16:creationId xmlns:a16="http://schemas.microsoft.com/office/drawing/2014/main" id="{7B903608-D048-42C8-AB2B-3D9B2A8ACD69}"/>
               </a:ext>
             </a:extLst>
           </p:cNvPr>
@@ -6623,7 +6623,7 @@
           <p:cNvPr id="13" name="">
             <a:extLst xmlns:a="http://schemas.openxmlformats.org/drawingml/2006/main">
               <a:ext uri="{FF2B5EF4-FFF2-40B4-BE49-F238E27FC236}">
-                <a16:creationId xmlns:a16="http://schemas.microsoft.com/office/drawing/2014/main" id="{D9EE630E-147D-4071-9DD4-30A3412E972A}"/>
+                <a16:creationId xmlns:a16="http://schemas.microsoft.com/office/drawing/2014/main" id="{0DA70CCB-6B7D-4B88-8A40-5205EE045011}"/>
               </a:ext>
             </a:extLst>
           </p:cNvPr>
@@ -6802,7 +6802,7 @@
           <p:cNvPr id="14" name="">
             <a:extLst xmlns:a="http://schemas.openxmlformats.org/drawingml/2006/main">
               <a:ext uri="{FF2B5EF4-FFF2-40B4-BE49-F238E27FC236}">
-                <a16:creationId xmlns:a16="http://schemas.microsoft.com/office/drawing/2014/main" id="{6541D09D-0E21-4A50-8FAE-3A74F81B1C72}"/>
+                <a16:creationId xmlns:a16="http://schemas.microsoft.com/office/drawing/2014/main" id="{BEC9E895-19E0-46DD-9F83-9F42B746CF11}"/>
               </a:ext>
             </a:extLst>
           </p:cNvPr>
@@ -6834,7 +6834,7 @@
           <p:cNvPr id="15" name="">
             <a:extLst xmlns:a="http://schemas.openxmlformats.org/drawingml/2006/main">
               <a:ext uri="{FF2B5EF4-FFF2-40B4-BE49-F238E27FC236}">
-                <a16:creationId xmlns:a16="http://schemas.microsoft.com/office/drawing/2014/main" id="{AF469AE1-A4DF-4D58-BB35-40E58F2B7E98}"/>
+                <a16:creationId xmlns:a16="http://schemas.microsoft.com/office/drawing/2014/main" id="{CDA81AB5-F6D3-4147-805E-62F0C45FBA5E}"/>
               </a:ext>
             </a:extLst>
           </p:cNvPr>
@@ -7013,7 +7013,7 @@
           <p:cNvPr id="19" name="">
             <a:extLst xmlns:a="http://schemas.openxmlformats.org/drawingml/2006/main">
               <a:ext uri="{FF2B5EF4-FFF2-40B4-BE49-F238E27FC236}">
-                <a16:creationId xmlns:a16="http://schemas.microsoft.com/office/drawing/2014/main" id="{A4CDE465-4679-4759-9F99-E093AE63B1E5}"/>
+                <a16:creationId xmlns:a16="http://schemas.microsoft.com/office/drawing/2014/main" id="{1C07AD83-05D5-47B9-BD36-8EB0DC0600C9}"/>
               </a:ext>
             </a:extLst>
           </p:cNvPr>
@@ -7041,7 +7041,7 @@
           <p:cNvPr id="20" name="">
             <a:extLst xmlns:a="http://schemas.openxmlformats.org/drawingml/2006/main">
               <a:ext uri="{FF2B5EF4-FFF2-40B4-BE49-F238E27FC236}">
-                <a16:creationId xmlns:a16="http://schemas.microsoft.com/office/drawing/2014/main" id="{A52419EE-2FFF-4CC3-9456-8C3843CB871B}"/>
+                <a16:creationId xmlns:a16="http://schemas.microsoft.com/office/drawing/2014/main" id="{ABCC9732-68CE-4283-8AA4-BC542D99A04F}"/>
               </a:ext>
             </a:extLst>
           </p:cNvPr>
@@ -7069,7 +7069,7 @@
           <p:cNvPr id="21" name="">
             <a:extLst xmlns:a="http://schemas.openxmlformats.org/drawingml/2006/main">
               <a:ext uri="{FF2B5EF4-FFF2-40B4-BE49-F238E27FC236}">
-                <a16:creationId xmlns:a16="http://schemas.microsoft.com/office/drawing/2014/main" id="{DDC5246F-CFFF-4A8D-B517-96471F618556}"/>
+                <a16:creationId xmlns:a16="http://schemas.microsoft.com/office/drawing/2014/main" id="{15C6FB60-EBC2-4769-ADA9-52CCC7F33D80}"/>
               </a:ext>
             </a:extLst>
           </p:cNvPr>
@@ -7098,7 +7098,7 @@
           <p:cNvPr id="23" name="">
             <a:extLst xmlns:a="http://schemas.openxmlformats.org/drawingml/2006/main">
               <a:ext uri="{FF2B5EF4-FFF2-40B4-BE49-F238E27FC236}">
-                <a16:creationId xmlns:a16="http://schemas.microsoft.com/office/drawing/2014/main" id="{3BBAB112-0D6B-4327-8614-6B956DF2353E}"/>
+                <a16:creationId xmlns:a16="http://schemas.microsoft.com/office/drawing/2014/main" id="{BFB92602-D7AC-4B19-980D-C396878DC938}"/>
               </a:ext>
             </a:extLst>
           </p:cNvPr>
@@ -7254,7 +7254,7 @@
           <p:cNvPr id="24" name="">
             <a:extLst xmlns:a="http://schemas.openxmlformats.org/drawingml/2006/main">
               <a:ext uri="{FF2B5EF4-FFF2-40B4-BE49-F238E27FC236}">
-                <a16:creationId xmlns:a16="http://schemas.microsoft.com/office/drawing/2014/main" id="{EC85F192-5506-4DDC-8EC1-D33D9C091594}"/>
+                <a16:creationId xmlns:a16="http://schemas.microsoft.com/office/drawing/2014/main" id="{08A7AA2F-9EB4-4C05-8AC2-8550FAD65522}"/>
               </a:ext>
             </a:extLst>
           </p:cNvPr>
@@ -7410,7 +7410,7 @@
           <p:cNvPr id="25" name="">
             <a:extLst xmlns:a="http://schemas.openxmlformats.org/drawingml/2006/main">
               <a:ext uri="{FF2B5EF4-FFF2-40B4-BE49-F238E27FC236}">
-                <a16:creationId xmlns:a16="http://schemas.microsoft.com/office/drawing/2014/main" id="{3C8B7D6D-0A97-4A52-8072-38ACFA0036A0}"/>
+                <a16:creationId xmlns:a16="http://schemas.microsoft.com/office/drawing/2014/main" id="{AF2028C5-2AAD-42CE-9629-9B6FABE255E3}"/>
               </a:ext>
             </a:extLst>
           </p:cNvPr>
@@ -7587,7 +7587,7 @@
     </p:spTree>
     <p:extLst>
       <p:ext uri="{BB962C8B-B14F-4D97-AF65-F5344CB8AC3E}">
-        <p14:creationId xmlns:p14="http://schemas.microsoft.com/office/powerpoint/2010/main" val="1080541969"/>
+        <p14:creationId xmlns:p14="http://schemas.microsoft.com/office/powerpoint/2010/main" val="1779481793"/>
       </p:ext>
     </p:extLst>
   </p:cSld>
@@ -7618,7 +7618,7 @@
           <p:cNvPr id="5" name="">
             <a:extLst xmlns:a="http://schemas.openxmlformats.org/drawingml/2006/main">
               <a:ext uri="{FF2B5EF4-FFF2-40B4-BE49-F238E27FC236}">
-                <a16:creationId xmlns:a16="http://schemas.microsoft.com/office/drawing/2014/main" id="{044A15FF-9A25-49E4-B858-893342E5B01D}"/>
+                <a16:creationId xmlns:a16="http://schemas.microsoft.com/office/drawing/2014/main" id="{F7E6B8CD-361F-4306-B19A-40AACF22944D}"/>
               </a:ext>
             </a:extLst>
           </p:cNvPr>
@@ -7774,7 +7774,7 @@
           <p:cNvPr id="2" name="">
             <a:extLst xmlns:a="http://schemas.openxmlformats.org/drawingml/2006/main">
               <a:ext uri="{FF2B5EF4-FFF2-40B4-BE49-F238E27FC236}">
-                <a16:creationId xmlns:a16="http://schemas.microsoft.com/office/drawing/2014/main" id="{38C9D1FA-4A5A-4540-B6F8-3825DF5689E2}"/>
+                <a16:creationId xmlns:a16="http://schemas.microsoft.com/office/drawing/2014/main" id="{7C3D60A1-A79F-450F-B3CE-94671DF096A4}"/>
               </a:ext>
             </a:extLst>
           </p:cNvPr>
@@ -7930,7 +7930,7 @@
           <p:cNvPr id="3" name="">
             <a:extLst xmlns:a="http://schemas.openxmlformats.org/drawingml/2006/main">
               <a:ext uri="{FF2B5EF4-FFF2-40B4-BE49-F238E27FC236}">
-                <a16:creationId xmlns:a16="http://schemas.microsoft.com/office/drawing/2014/main" id="{D8B1A80F-EED6-40E6-80D1-F555103EA1CE}"/>
+                <a16:creationId xmlns:a16="http://schemas.microsoft.com/office/drawing/2014/main" id="{C0CBD4CD-1C44-4E4E-B3EE-33F38DBDB00A}"/>
               </a:ext>
             </a:extLst>
           </p:cNvPr>
@@ -8086,7 +8086,7 @@
           <p:cNvPr id="4" name="">
             <a:extLst xmlns:a="http://schemas.openxmlformats.org/drawingml/2006/main">
               <a:ext uri="{FF2B5EF4-FFF2-40B4-BE49-F238E27FC236}">
-                <a16:creationId xmlns:a16="http://schemas.microsoft.com/office/drawing/2014/main" id="{5EDF5011-5F6E-4D45-9F20-045653A862AB}"/>
+                <a16:creationId xmlns:a16="http://schemas.microsoft.com/office/drawing/2014/main" id="{E7E0F547-48A1-4033-83B5-2ED00E346187}"/>
               </a:ext>
             </a:extLst>
           </p:cNvPr>
@@ -8710,7 +8710,7 @@
     </p:spTree>
     <p:extLst>
       <p:ext uri="{BB962C8B-B14F-4D97-AF65-F5344CB8AC3E}">
-        <p14:creationId xmlns:p14="http://schemas.microsoft.com/office/powerpoint/2010/main" val="1234690883"/>
+        <p14:creationId xmlns:p14="http://schemas.microsoft.com/office/powerpoint/2010/main" val="1411876269"/>
       </p:ext>
     </p:extLst>
   </p:cSld>
@@ -8741,7 +8741,7 @@
           <p:cNvPr id="14" name="">
             <a:extLst xmlns:a="http://schemas.openxmlformats.org/drawingml/2006/main">
               <a:ext uri="{FF2B5EF4-FFF2-40B4-BE49-F238E27FC236}">
-                <a16:creationId xmlns:a16="http://schemas.microsoft.com/office/drawing/2014/main" id="{CDA541DA-1F79-4067-94EE-40AF66D0D545}"/>
+                <a16:creationId xmlns:a16="http://schemas.microsoft.com/office/drawing/2014/main" id="{82CA0D36-153C-4B4C-9621-58587EAE4393}"/>
               </a:ext>
             </a:extLst>
           </p:cNvPr>
@@ -8897,7 +8897,7 @@
           <p:cNvPr id="2" name="">
             <a:extLst xmlns:a="http://schemas.openxmlformats.org/drawingml/2006/main">
               <a:ext uri="{FF2B5EF4-FFF2-40B4-BE49-F238E27FC236}">
-                <a16:creationId xmlns:a16="http://schemas.microsoft.com/office/drawing/2014/main" id="{AA947555-E2CF-4F0E-B437-814EE8F89FBD}"/>
+                <a16:creationId xmlns:a16="http://schemas.microsoft.com/office/drawing/2014/main" id="{A865DCD9-E7A7-4E72-BEC9-49627E4F6B75}"/>
               </a:ext>
             </a:extLst>
           </p:cNvPr>
@@ -9053,7 +9053,7 @@
           <p:cNvPr id="3" name="">
             <a:extLst xmlns:a="http://schemas.openxmlformats.org/drawingml/2006/main">
               <a:ext uri="{FF2B5EF4-FFF2-40B4-BE49-F238E27FC236}">
-                <a16:creationId xmlns:a16="http://schemas.microsoft.com/office/drawing/2014/main" id="{D6683EBE-70AD-4723-8A70-1637265C1489}"/>
+                <a16:creationId xmlns:a16="http://schemas.microsoft.com/office/drawing/2014/main" id="{A63DE473-5A19-4F3A-97B2-94CAC24A09E5}"/>
               </a:ext>
             </a:extLst>
           </p:cNvPr>
@@ -9209,7 +9209,7 @@
           <p:cNvPr id="4" name="">
             <a:extLst xmlns:a="http://schemas.openxmlformats.org/drawingml/2006/main">
               <a:ext uri="{FF2B5EF4-FFF2-40B4-BE49-F238E27FC236}">
-                <a16:creationId xmlns:a16="http://schemas.microsoft.com/office/drawing/2014/main" id="{E427B7C1-B783-4D11-A60B-BE82384989FE}"/>
+                <a16:creationId xmlns:a16="http://schemas.microsoft.com/office/drawing/2014/main" id="{C446C189-8CBB-4212-8265-520B4AF8D3B2}"/>
               </a:ext>
             </a:extLst>
           </p:cNvPr>
@@ -9365,7 +9365,7 @@
           <p:cNvPr id="5" name="">
             <a:extLst xmlns:a="http://schemas.openxmlformats.org/drawingml/2006/main">
               <a:ext uri="{FF2B5EF4-FFF2-40B4-BE49-F238E27FC236}">
-                <a16:creationId xmlns:a16="http://schemas.microsoft.com/office/drawing/2014/main" id="{6916059C-B02A-4698-9B03-0F24F5D649A5}"/>
+                <a16:creationId xmlns:a16="http://schemas.microsoft.com/office/drawing/2014/main" id="{C01A9C95-1371-4095-B2BE-7B03104C6CE4}"/>
               </a:ext>
             </a:extLst>
           </p:cNvPr>
@@ -9521,7 +9521,7 @@
           <p:cNvPr id="6" name="">
             <a:extLst xmlns:a="http://schemas.openxmlformats.org/drawingml/2006/main">
               <a:ext uri="{FF2B5EF4-FFF2-40B4-BE49-F238E27FC236}">
-                <a16:creationId xmlns:a16="http://schemas.microsoft.com/office/drawing/2014/main" id="{D6901468-97A2-48C6-AABA-82EDBC67016D}"/>
+                <a16:creationId xmlns:a16="http://schemas.microsoft.com/office/drawing/2014/main" id="{AF37ADFF-E45B-4F5A-997B-C0512165290E}"/>
               </a:ext>
             </a:extLst>
           </p:cNvPr>
@@ -9700,7 +9700,7 @@
           <p:cNvPr id="7" name="">
             <a:extLst xmlns:a="http://schemas.openxmlformats.org/drawingml/2006/main">
               <a:ext uri="{FF2B5EF4-FFF2-40B4-BE49-F238E27FC236}">
-                <a16:creationId xmlns:a16="http://schemas.microsoft.com/office/drawing/2014/main" id="{D852E0A9-1ADB-46CB-8CC9-9BC83C1EEA4D}"/>
+                <a16:creationId xmlns:a16="http://schemas.microsoft.com/office/drawing/2014/main" id="{708E1652-3249-4C80-91D5-A7792BDD1EEB}"/>
               </a:ext>
             </a:extLst>
           </p:cNvPr>
@@ -9879,7 +9879,7 @@
           <p:cNvPr id="8" name="">
             <a:extLst xmlns:a="http://schemas.openxmlformats.org/drawingml/2006/main">
               <a:ext uri="{FF2B5EF4-FFF2-40B4-BE49-F238E27FC236}">
-                <a16:creationId xmlns:a16="http://schemas.microsoft.com/office/drawing/2014/main" id="{5D81891F-E94E-45D6-B4E4-F86F7BC48DF0}"/>
+                <a16:creationId xmlns:a16="http://schemas.microsoft.com/office/drawing/2014/main" id="{D64908C2-C55A-4B51-9D27-DC9BCFBD0ECE}"/>
               </a:ext>
             </a:extLst>
           </p:cNvPr>
@@ -10058,7 +10058,7 @@
           <p:cNvPr id="9" name="">
             <a:extLst xmlns:a="http://schemas.openxmlformats.org/drawingml/2006/main">
               <a:ext uri="{FF2B5EF4-FFF2-40B4-BE49-F238E27FC236}">
-                <a16:creationId xmlns:a16="http://schemas.microsoft.com/office/drawing/2014/main" id="{71028332-1D21-4850-A755-97DA8FA18494}"/>
+                <a16:creationId xmlns:a16="http://schemas.microsoft.com/office/drawing/2014/main" id="{D81997C9-1047-4C70-839A-0C21156701CF}"/>
               </a:ext>
             </a:extLst>
           </p:cNvPr>
@@ -10214,7 +10214,7 @@
           <p:cNvPr id="10" name="">
             <a:extLst xmlns:a="http://schemas.openxmlformats.org/drawingml/2006/main">
               <a:ext uri="{FF2B5EF4-FFF2-40B4-BE49-F238E27FC236}">
-                <a16:creationId xmlns:a16="http://schemas.microsoft.com/office/drawing/2014/main" id="{A59E58FA-1B4B-4FA9-8D70-06AFDDF5B9F2}"/>
+                <a16:creationId xmlns:a16="http://schemas.microsoft.com/office/drawing/2014/main" id="{E09C2EC4-5264-453E-B331-CF7E8F1DC328}"/>
               </a:ext>
             </a:extLst>
           </p:cNvPr>
@@ -10370,7 +10370,7 @@
           <p:cNvPr id="11" name="">
             <a:extLst xmlns:a="http://schemas.openxmlformats.org/drawingml/2006/main">
               <a:ext uri="{FF2B5EF4-FFF2-40B4-BE49-F238E27FC236}">
-                <a16:creationId xmlns:a16="http://schemas.microsoft.com/office/drawing/2014/main" id="{B2958073-CF0E-4EBC-A6FD-67D5EDD7AB11}"/>
+                <a16:creationId xmlns:a16="http://schemas.microsoft.com/office/drawing/2014/main" id="{D7BA17A1-035E-4928-92D4-A158F9B97A2D}"/>
               </a:ext>
             </a:extLst>
           </p:cNvPr>
@@ -10526,7 +10526,7 @@
           <p:cNvPr id="12" name="">
             <a:extLst xmlns:a="http://schemas.openxmlformats.org/drawingml/2006/main">
               <a:ext uri="{FF2B5EF4-FFF2-40B4-BE49-F238E27FC236}">
-                <a16:creationId xmlns:a16="http://schemas.microsoft.com/office/drawing/2014/main" id="{B8B2C247-73CF-4865-86F1-60DFB0FC9DD4}"/>
+                <a16:creationId xmlns:a16="http://schemas.microsoft.com/office/drawing/2014/main" id="{1DDD3202-5BCA-402A-AB76-F85F50D22A1E}"/>
               </a:ext>
             </a:extLst>
           </p:cNvPr>
@@ -10728,7 +10728,7 @@
           <p:cNvPr id="13" name="">
             <a:extLst xmlns:a="http://schemas.openxmlformats.org/drawingml/2006/main">
               <a:ext uri="{FF2B5EF4-FFF2-40B4-BE49-F238E27FC236}">
-                <a16:creationId xmlns:a16="http://schemas.microsoft.com/office/drawing/2014/main" id="{1160A5B1-59EB-4530-8936-D12E267AC452}"/>
+                <a16:creationId xmlns:a16="http://schemas.microsoft.com/office/drawing/2014/main" id="{3CE91DE2-D1D1-43AC-B23C-CEFF13D323CC}"/>
               </a:ext>
             </a:extLst>
           </p:cNvPr>
@@ -10905,7 +10905,7 @@
     </p:spTree>
     <p:extLst>
       <p:ext uri="{BB962C8B-B14F-4D97-AF65-F5344CB8AC3E}">
-        <p14:creationId xmlns:p14="http://schemas.microsoft.com/office/powerpoint/2010/main" val="418984993"/>
+        <p14:creationId xmlns:p14="http://schemas.microsoft.com/office/powerpoint/2010/main" val="1902146205"/>
       </p:ext>
     </p:extLst>
   </p:cSld>
@@ -10936,7 +10936,7 @@
           <p:cNvPr id="13" name="">
             <a:extLst xmlns:a="http://schemas.openxmlformats.org/drawingml/2006/main">
               <a:ext uri="{FF2B5EF4-FFF2-40B4-BE49-F238E27FC236}">
-                <a16:creationId xmlns:a16="http://schemas.microsoft.com/office/drawing/2014/main" id="{1BC6FAF5-A03D-4242-90D3-21FE74C70C73}"/>
+                <a16:creationId xmlns:a16="http://schemas.microsoft.com/office/drawing/2014/main" id="{6879EB8C-B63B-4DC7-B5FF-8C8C8EC05534}"/>
               </a:ext>
             </a:extLst>
           </p:cNvPr>
@@ -11092,7 +11092,7 @@
           <p:cNvPr id="2" name="">
             <a:extLst xmlns:a="http://schemas.openxmlformats.org/drawingml/2006/main">
               <a:ext uri="{FF2B5EF4-FFF2-40B4-BE49-F238E27FC236}">
-                <a16:creationId xmlns:a16="http://schemas.microsoft.com/office/drawing/2014/main" id="{3384C3D5-72C1-411F-89E0-CF19EF9A1271}"/>
+                <a16:creationId xmlns:a16="http://schemas.microsoft.com/office/drawing/2014/main" id="{9C7E3E84-AD6E-4BAE-962C-9CDB60D3B157}"/>
               </a:ext>
             </a:extLst>
           </p:cNvPr>
@@ -11248,7 +11248,7 @@
           <p:cNvPr id="3" name="">
             <a:extLst xmlns:a="http://schemas.openxmlformats.org/drawingml/2006/main">
               <a:ext uri="{FF2B5EF4-FFF2-40B4-BE49-F238E27FC236}">
-                <a16:creationId xmlns:a16="http://schemas.microsoft.com/office/drawing/2014/main" id="{1E16ACA3-1E23-4BFD-B916-B5A4AA8343FA}"/>
+                <a16:creationId xmlns:a16="http://schemas.microsoft.com/office/drawing/2014/main" id="{637F1340-9F8C-47EE-96D2-B1CD1CF0C7B1}"/>
               </a:ext>
             </a:extLst>
           </p:cNvPr>
@@ -11404,7 +11404,7 @@
           <p:cNvPr id="4" name="">
             <a:extLst xmlns:a="http://schemas.openxmlformats.org/drawingml/2006/main">
               <a:ext uri="{FF2B5EF4-FFF2-40B4-BE49-F238E27FC236}">
-                <a16:creationId xmlns:a16="http://schemas.microsoft.com/office/drawing/2014/main" id="{F1D29F64-C280-4F71-9EA2-D9A36016D586}"/>
+                <a16:creationId xmlns:a16="http://schemas.microsoft.com/office/drawing/2014/main" id="{3F210834-E812-44B6-8D94-BD043E99A2CA}"/>
               </a:ext>
             </a:extLst>
           </p:cNvPr>
@@ -11560,7 +11560,7 @@
           <p:cNvPr id="5" name="">
             <a:extLst xmlns:a="http://schemas.openxmlformats.org/drawingml/2006/main">
               <a:ext uri="{FF2B5EF4-FFF2-40B4-BE49-F238E27FC236}">
-                <a16:creationId xmlns:a16="http://schemas.microsoft.com/office/drawing/2014/main" id="{64887A17-A89E-4AAB-AC9C-271A2472A0B3}"/>
+                <a16:creationId xmlns:a16="http://schemas.microsoft.com/office/drawing/2014/main" id="{AEC5D6D2-9424-4CA2-AFC8-9EE54F5797F0}"/>
               </a:ext>
             </a:extLst>
           </p:cNvPr>
@@ -11716,7 +11716,7 @@
           <p:cNvPr id="6" name="">
             <a:extLst xmlns:a="http://schemas.openxmlformats.org/drawingml/2006/main">
               <a:ext uri="{FF2B5EF4-FFF2-40B4-BE49-F238E27FC236}">
-                <a16:creationId xmlns:a16="http://schemas.microsoft.com/office/drawing/2014/main" id="{360298AA-B87F-4D1C-9BF5-2CE0AE25C128}"/>
+                <a16:creationId xmlns:a16="http://schemas.microsoft.com/office/drawing/2014/main" id="{12BB192E-7D9C-4AF7-A733-2443AEBB3429}"/>
               </a:ext>
             </a:extLst>
           </p:cNvPr>
@@ -11918,7 +11918,7 @@
           <p:cNvPr id="7" name="">
             <a:extLst xmlns:a="http://schemas.openxmlformats.org/drawingml/2006/main">
               <a:ext uri="{FF2B5EF4-FFF2-40B4-BE49-F238E27FC236}">
-                <a16:creationId xmlns:a16="http://schemas.microsoft.com/office/drawing/2014/main" id="{55C3F64E-235B-41EA-BA4C-699FD6825774}"/>
+                <a16:creationId xmlns:a16="http://schemas.microsoft.com/office/drawing/2014/main" id="{15761226-F033-49BB-BE0D-A8AE76B5F16E}"/>
               </a:ext>
             </a:extLst>
           </p:cNvPr>
@@ -12074,7 +12074,7 @@
           <p:cNvPr id="8" name="">
             <a:extLst xmlns:a="http://schemas.openxmlformats.org/drawingml/2006/main">
               <a:ext uri="{FF2B5EF4-FFF2-40B4-BE49-F238E27FC236}">
-                <a16:creationId xmlns:a16="http://schemas.microsoft.com/office/drawing/2014/main" id="{55553F87-D0AB-4602-AF6B-A6D483AE5D8A}"/>
+                <a16:creationId xmlns:a16="http://schemas.microsoft.com/office/drawing/2014/main" id="{6CBD31EF-03BB-4ED9-8431-7A5252FE02B6}"/>
               </a:ext>
             </a:extLst>
           </p:cNvPr>
@@ -12276,7 +12276,7 @@
           <p:cNvPr id="9" name="">
             <a:extLst xmlns:a="http://schemas.openxmlformats.org/drawingml/2006/main">
               <a:ext uri="{FF2B5EF4-FFF2-40B4-BE49-F238E27FC236}">
-                <a16:creationId xmlns:a16="http://schemas.microsoft.com/office/drawing/2014/main" id="{DD83B8D3-4965-4137-86AE-26E60C5A4FAE}"/>
+                <a16:creationId xmlns:a16="http://schemas.microsoft.com/office/drawing/2014/main" id="{B909DC25-93BF-4A89-B671-B3DD479546B0}"/>
               </a:ext>
             </a:extLst>
           </p:cNvPr>
@@ -12432,7 +12432,7 @@
           <p:cNvPr id="10" name="">
             <a:extLst xmlns:a="http://schemas.openxmlformats.org/drawingml/2006/main">
               <a:ext uri="{FF2B5EF4-FFF2-40B4-BE49-F238E27FC236}">
-                <a16:creationId xmlns:a16="http://schemas.microsoft.com/office/drawing/2014/main" id="{2CF4B518-9300-4614-A56D-7954EA498781}"/>
+                <a16:creationId xmlns:a16="http://schemas.microsoft.com/office/drawing/2014/main" id="{658A4A82-1500-4AD7-82A5-C42428E99328}"/>
               </a:ext>
             </a:extLst>
           </p:cNvPr>
@@ -12588,7 +12588,7 @@
           <p:cNvPr id="11" name="">
             <a:extLst xmlns:a="http://schemas.openxmlformats.org/drawingml/2006/main">
               <a:ext uri="{FF2B5EF4-FFF2-40B4-BE49-F238E27FC236}">
-                <a16:creationId xmlns:a16="http://schemas.microsoft.com/office/drawing/2014/main" id="{F2B717D2-4746-47F5-8566-EDEDA31D39B0}"/>
+                <a16:creationId xmlns:a16="http://schemas.microsoft.com/office/drawing/2014/main" id="{6E0D65ED-7871-49B3-8E84-6DA153B12C56}"/>
               </a:ext>
             </a:extLst>
           </p:cNvPr>
@@ -12790,7 +12790,7 @@
           <p:cNvPr id="12" name="">
             <a:extLst xmlns:a="http://schemas.openxmlformats.org/drawingml/2006/main">
               <a:ext uri="{FF2B5EF4-FFF2-40B4-BE49-F238E27FC236}">
-                <a16:creationId xmlns:a16="http://schemas.microsoft.com/office/drawing/2014/main" id="{AD9D1B99-2FFD-4C0F-B705-B867E793BCDB}"/>
+                <a16:creationId xmlns:a16="http://schemas.microsoft.com/office/drawing/2014/main" id="{5B7729D5-31E1-4002-A463-ADFA29682797}"/>
               </a:ext>
             </a:extLst>
           </p:cNvPr>
@@ -12936,7 +12936,7 @@
                 <a:ea typeface="Arial"/>
                 <a:cs typeface="Arial"/>
               </a:rPr>
-              <a:t>Chosen Apple profile only.</a:t>
+              <a:t>Proved with Apple profile.</a:t>
             </a:r>
           </a:p>
           <a:p xmlns:a="http://schemas.openxmlformats.org/drawingml/2006/main">
@@ -12990,7 +12990,7 @@
     </p:spTree>
     <p:extLst>
       <p:ext uri="{BB962C8B-B14F-4D97-AF65-F5344CB8AC3E}">
-        <p14:creationId xmlns:p14="http://schemas.microsoft.com/office/powerpoint/2010/main" val="1956178763"/>
+        <p14:creationId xmlns:p14="http://schemas.microsoft.com/office/powerpoint/2010/main" val="1230607063"/>
       </p:ext>
     </p:extLst>
   </p:cSld>

</xml_diff>

<commit_message>
Credit Dr Geoff Cheng on presentation cover
</commit_message>
<xml_diff>
--- a/slides/london-office-monitoring.pptx
+++ b/slides/london-office-monitoring.pptx
@@ -2,17 +2,17 @@
 <file path=ppt/presentation.xml><?xml version="1.0" encoding="utf-8"?>
 <p:presentation xmlns:p="http://schemas.openxmlformats.org/presentationml/2006/main">
   <p:sldMasterIdLst>
-    <p:sldMasterId xmlns:r="http://schemas.openxmlformats.org/officeDocument/2006/relationships" id="2147483648" r:id="R771c085644ee402f"/>
+    <p:sldMasterId xmlns:r="http://schemas.openxmlformats.org/officeDocument/2006/relationships" id="2147483648" r:id="Rddcfa6f6e3e44e15"/>
   </p:sldMasterIdLst>
   <p:notesMasterIdLst>
-    <p:notesMasterId xmlns:r="http://schemas.openxmlformats.org/officeDocument/2006/relationships" r:id="R9dcf52f91b33405b"/>
+    <p:notesMasterId xmlns:r="http://schemas.openxmlformats.org/officeDocument/2006/relationships" r:id="R3b3f7832b91f4100"/>
   </p:notesMasterIdLst>
   <p:sldIdLst>
-    <p:sldId xmlns:r="http://schemas.openxmlformats.org/officeDocument/2006/relationships" id="256" r:id="R2fe287a8db794c0e"/>
-    <p:sldId xmlns:r="http://schemas.openxmlformats.org/officeDocument/2006/relationships" id="257" r:id="Rd5593be975794ab2"/>
-    <p:sldId xmlns:r="http://schemas.openxmlformats.org/officeDocument/2006/relationships" id="258" r:id="Ra3e8e2c8b2104e11"/>
-    <p:sldId xmlns:r="http://schemas.openxmlformats.org/officeDocument/2006/relationships" id="259" r:id="Rf606b12e52c74886"/>
-    <p:sldId xmlns:r="http://schemas.openxmlformats.org/officeDocument/2006/relationships" id="260" r:id="R294b8ea3384d44ea"/>
+    <p:sldId xmlns:r="http://schemas.openxmlformats.org/officeDocument/2006/relationships" id="256" r:id="R0f149e7a92af4ccb"/>
+    <p:sldId xmlns:r="http://schemas.openxmlformats.org/officeDocument/2006/relationships" id="257" r:id="R9deda41c663d4d0c"/>
+    <p:sldId xmlns:r="http://schemas.openxmlformats.org/officeDocument/2006/relationships" id="258" r:id="Rce9e0626773043a9"/>
+    <p:sldId xmlns:r="http://schemas.openxmlformats.org/officeDocument/2006/relationships" id="259" r:id="Re8166e9803cc48d0"/>
+    <p:sldId xmlns:r="http://schemas.openxmlformats.org/officeDocument/2006/relationships" id="260" r:id="R280605f365d84e51"/>
   </p:sldIdLst>
   <p:sldSz cx="12192000" cy="6858000"/>
   <p:notesSz cx="6858000" cy="9144000"/>
@@ -773,7 +773,7 @@
           <p:cNvPr id="3" name="Title">
             <a:extLst xmlns:a="http://schemas.openxmlformats.org/drawingml/2006/main">
               <a:ext uri="{FF2B5EF4-FFF2-40B4-BE49-F238E27FC236}">
-                <a16:creationId xmlns:a16="http://schemas.microsoft.com/office/drawing/2014/main" id="{2792841E-D44C-4ECE-94AE-2E093663EB10}"/>
+                <a16:creationId xmlns:a16="http://schemas.microsoft.com/office/drawing/2014/main" id="{03584D8F-8F12-403B-B034-8FDD8D11DD8F}"/>
               </a:ext>
             </a:extLst>
           </p:cNvPr>
@@ -1002,7 +1002,7 @@
           <p:cNvPr id="2" name="Subtitle">
             <a:extLst xmlns:a="http://schemas.openxmlformats.org/drawingml/2006/main">
               <a:ext uri="{FF2B5EF4-FFF2-40B4-BE49-F238E27FC236}">
-                <a16:creationId xmlns:a16="http://schemas.microsoft.com/office/drawing/2014/main" id="{4B7D9868-D706-454B-BACB-95812414B064}"/>
+                <a16:creationId xmlns:a16="http://schemas.microsoft.com/office/drawing/2014/main" id="{C360F873-56C3-42CC-AFB2-951DB7F53342}"/>
               </a:ext>
             </a:extLst>
           </p:cNvPr>
@@ -1248,7 +1248,7 @@
           <p:cNvPr id="2" name="Section title">
             <a:extLst xmlns:a="http://schemas.openxmlformats.org/drawingml/2006/main">
               <a:ext uri="{FF2B5EF4-FFF2-40B4-BE49-F238E27FC236}">
-                <a16:creationId xmlns:a16="http://schemas.microsoft.com/office/drawing/2014/main" id="{D50D1066-D559-4241-81C7-90C80AC97D0C}"/>
+                <a16:creationId xmlns:a16="http://schemas.microsoft.com/office/drawing/2014/main" id="{83B8A113-518A-48E8-84C2-EBB17D9FEDFC}"/>
               </a:ext>
             </a:extLst>
           </p:cNvPr>
@@ -1494,7 +1494,7 @@
           <p:cNvPr id="3" name="Title">
             <a:extLst xmlns:a="http://schemas.openxmlformats.org/drawingml/2006/main">
               <a:ext uri="{FF2B5EF4-FFF2-40B4-BE49-F238E27FC236}">
-                <a16:creationId xmlns:a16="http://schemas.microsoft.com/office/drawing/2014/main" id="{861B6AB9-B1DC-4219-92AA-B9CF7518BAEF}"/>
+                <a16:creationId xmlns:a16="http://schemas.microsoft.com/office/drawing/2014/main" id="{BAA3A085-82A0-4064-90A4-90B1DAED7EBC}"/>
               </a:ext>
             </a:extLst>
           </p:cNvPr>
@@ -1723,7 +1723,7 @@
           <p:cNvPr id="2" name="Body">
             <a:extLst xmlns:a="http://schemas.openxmlformats.org/drawingml/2006/main">
               <a:ext uri="{FF2B5EF4-FFF2-40B4-BE49-F238E27FC236}">
-                <a16:creationId xmlns:a16="http://schemas.microsoft.com/office/drawing/2014/main" id="{6172BBE9-E6A5-497A-A325-5E69029773A9}"/>
+                <a16:creationId xmlns:a16="http://schemas.microsoft.com/office/drawing/2014/main" id="{298E008F-1F70-414A-9716-59AFD4C71D8D}"/>
               </a:ext>
             </a:extLst>
           </p:cNvPr>
@@ -1969,7 +1969,7 @@
           <p:cNvPr id="4" name="Title">
             <a:extLst xmlns:a="http://schemas.openxmlformats.org/drawingml/2006/main">
               <a:ext uri="{FF2B5EF4-FFF2-40B4-BE49-F238E27FC236}">
-                <a16:creationId xmlns:a16="http://schemas.microsoft.com/office/drawing/2014/main" id="{99C2A397-3B23-4621-86D6-AA867802CFEB}"/>
+                <a16:creationId xmlns:a16="http://schemas.microsoft.com/office/drawing/2014/main" id="{9659A3F1-1F00-4292-96B1-9B0F8D7ACE08}"/>
               </a:ext>
             </a:extLst>
           </p:cNvPr>
@@ -2198,7 +2198,7 @@
           <p:cNvPr id="2" name="Left column">
             <a:extLst xmlns:a="http://schemas.openxmlformats.org/drawingml/2006/main">
               <a:ext uri="{FF2B5EF4-FFF2-40B4-BE49-F238E27FC236}">
-                <a16:creationId xmlns:a16="http://schemas.microsoft.com/office/drawing/2014/main" id="{D82E0304-342B-4489-9D28-66F71D4A84DA}"/>
+                <a16:creationId xmlns:a16="http://schemas.microsoft.com/office/drawing/2014/main" id="{BCAE1DA9-BED8-4884-939D-2CE9B91E9A06}"/>
               </a:ext>
             </a:extLst>
           </p:cNvPr>
@@ -2427,7 +2427,7 @@
           <p:cNvPr id="3" name="Right column">
             <a:extLst xmlns:a="http://schemas.openxmlformats.org/drawingml/2006/main">
               <a:ext uri="{FF2B5EF4-FFF2-40B4-BE49-F238E27FC236}">
-                <a16:creationId xmlns:a16="http://schemas.microsoft.com/office/drawing/2014/main" id="{12BA8364-D640-4912-A31A-1CC3EDB79D3E}"/>
+                <a16:creationId xmlns:a16="http://schemas.microsoft.com/office/drawing/2014/main" id="{35554B2F-AB7C-4F07-A413-85F886D0620C}"/>
               </a:ext>
             </a:extLst>
           </p:cNvPr>
@@ -2673,7 +2673,7 @@
           <p:cNvPr id="3" name="Title">
             <a:extLst xmlns:a="http://schemas.openxmlformats.org/drawingml/2006/main">
               <a:ext uri="{FF2B5EF4-FFF2-40B4-BE49-F238E27FC236}">
-                <a16:creationId xmlns:a16="http://schemas.microsoft.com/office/drawing/2014/main" id="{029978CC-92F8-44A7-BD8D-2D089CF8027A}"/>
+                <a16:creationId xmlns:a16="http://schemas.microsoft.com/office/drawing/2014/main" id="{CC616939-5005-45CA-A591-586C3DA9B143}"/>
               </a:ext>
             </a:extLst>
           </p:cNvPr>
@@ -2902,7 +2902,7 @@
           <p:cNvPr id="2" name="Left column">
             <a:extLst xmlns:a="http://schemas.openxmlformats.org/drawingml/2006/main">
               <a:ext uri="{FF2B5EF4-FFF2-40B4-BE49-F238E27FC236}">
-                <a16:creationId xmlns:a16="http://schemas.microsoft.com/office/drawing/2014/main" id="{908AD3AB-923B-4B1C-9D7B-A1E291C68AE6}"/>
+                <a16:creationId xmlns:a16="http://schemas.microsoft.com/office/drawing/2014/main" id="{9C5EAB6D-1A66-49F0-8C71-4F30EAF276FA}"/>
               </a:ext>
             </a:extLst>
           </p:cNvPr>
@@ -3169,12 +3169,12 @@
   </p:cSld>
   <p:clrMap bg1="lt1" tx1="dk1" bg2="lt2" tx2="dk2" accent1="accent1" accent2="accent2" accent3="accent3" accent4="accent4" accent5="accent5" accent6="accent6" hlink="hlink" folHlink="folHlink"/>
   <p:sldLayoutIdLst>
-    <p:sldLayoutId xmlns:r="http://schemas.openxmlformats.org/officeDocument/2006/relationships" id="2147483649" r:id="R1c45517378b34800"/>
-    <p:sldLayoutId xmlns:r="http://schemas.openxmlformats.org/officeDocument/2006/relationships" id="2147483650" r:id="R098e7c72005f4a1c"/>
-    <p:sldLayoutId xmlns:r="http://schemas.openxmlformats.org/officeDocument/2006/relationships" id="2147483651" r:id="R84b6eebb501645b0"/>
-    <p:sldLayoutId xmlns:r="http://schemas.openxmlformats.org/officeDocument/2006/relationships" id="2147483652" r:id="R2607d1c471bc48a9"/>
-    <p:sldLayoutId xmlns:r="http://schemas.openxmlformats.org/officeDocument/2006/relationships" id="2147483653" r:id="R5136003263514ee2"/>
-    <p:sldLayoutId xmlns:r="http://schemas.openxmlformats.org/officeDocument/2006/relationships" id="2147483654" r:id="Rf94b156f45084ac5"/>
+    <p:sldLayoutId xmlns:r="http://schemas.openxmlformats.org/officeDocument/2006/relationships" id="2147483649" r:id="R1282b5935df64d8c"/>
+    <p:sldLayoutId xmlns:r="http://schemas.openxmlformats.org/officeDocument/2006/relationships" id="2147483650" r:id="R8529fc9e809c4115"/>
+    <p:sldLayoutId xmlns:r="http://schemas.openxmlformats.org/officeDocument/2006/relationships" id="2147483651" r:id="Rf34472d3a4014266"/>
+    <p:sldLayoutId xmlns:r="http://schemas.openxmlformats.org/officeDocument/2006/relationships" id="2147483652" r:id="R9cbac1f71ad54349"/>
+    <p:sldLayoutId xmlns:r="http://schemas.openxmlformats.org/officeDocument/2006/relationships" id="2147483653" r:id="Re85eb0b504d74b2f"/>
+    <p:sldLayoutId xmlns:r="http://schemas.openxmlformats.org/officeDocument/2006/relationships" id="2147483654" r:id="Rfc23256ccfe84334"/>
   </p:sldLayoutIdLst>
   <p:txStyles>
     <p:titleStyle>
@@ -3722,10 +3722,10 @@
       </p:grpSpPr>
       <p:sp>
         <p:nvSpPr>
-          <p:cNvPr id="9" name="">
+          <p:cNvPr id="10" name="">
             <a:extLst xmlns:a="http://schemas.openxmlformats.org/drawingml/2006/main">
               <a:ext uri="{FF2B5EF4-FFF2-40B4-BE49-F238E27FC236}">
-                <a16:creationId xmlns:a16="http://schemas.microsoft.com/office/drawing/2014/main" id="{CA1D682F-C22C-4E92-9ABE-F0DBB2E5B752}"/>
+                <a16:creationId xmlns:a16="http://schemas.microsoft.com/office/drawing/2014/main" id="{82B2C5CE-F487-4D0A-BDB1-3233DD812076}"/>
               </a:ext>
             </a:extLst>
           </p:cNvPr>
@@ -3881,7 +3881,7 @@
           <p:cNvPr id="2" name="">
             <a:extLst xmlns:a="http://schemas.openxmlformats.org/drawingml/2006/main">
               <a:ext uri="{FF2B5EF4-FFF2-40B4-BE49-F238E27FC236}">
-                <a16:creationId xmlns:a16="http://schemas.microsoft.com/office/drawing/2014/main" id="{3E754495-954B-4C5F-A4AC-D167C5FCEECC}"/>
+                <a16:creationId xmlns:a16="http://schemas.microsoft.com/office/drawing/2014/main" id="{4C5EC3A2-B033-4D0F-B314-49701148263E}"/>
               </a:ext>
             </a:extLst>
           </p:cNvPr>
@@ -4037,7 +4037,7 @@
           <p:cNvPr id="3" name="">
             <a:extLst xmlns:a="http://schemas.openxmlformats.org/drawingml/2006/main">
               <a:ext uri="{FF2B5EF4-FFF2-40B4-BE49-F238E27FC236}">
-                <a16:creationId xmlns:a16="http://schemas.microsoft.com/office/drawing/2014/main" id="{0E7B6CF8-F400-4A44-BFA5-087EFE81B45B}"/>
+                <a16:creationId xmlns:a16="http://schemas.microsoft.com/office/drawing/2014/main" id="{D101AB9E-9E44-4950-ACCE-92857F7629C2}"/>
               </a:ext>
             </a:extLst>
           </p:cNvPr>
@@ -4193,7 +4193,7 @@
           <p:cNvPr id="4" name="">
             <a:extLst xmlns:a="http://schemas.openxmlformats.org/drawingml/2006/main">
               <a:ext uri="{FF2B5EF4-FFF2-40B4-BE49-F238E27FC236}">
-                <a16:creationId xmlns:a16="http://schemas.microsoft.com/office/drawing/2014/main" id="{3414E401-C809-4C96-9560-1F36809F7FAF}"/>
+                <a16:creationId xmlns:a16="http://schemas.microsoft.com/office/drawing/2014/main" id="{A1EB413A-B3B3-4203-9CBB-95A686980AED}"/>
               </a:ext>
             </a:extLst>
           </p:cNvPr>
@@ -4372,7 +4372,7 @@
           <p:cNvPr id="5" name="">
             <a:extLst xmlns:a="http://schemas.openxmlformats.org/drawingml/2006/main">
               <a:ext uri="{FF2B5EF4-FFF2-40B4-BE49-F238E27FC236}">
-                <a16:creationId xmlns:a16="http://schemas.microsoft.com/office/drawing/2014/main" id="{92CB56DB-34BC-4C34-AD4A-84DAFC8CECAD}"/>
+                <a16:creationId xmlns:a16="http://schemas.microsoft.com/office/drawing/2014/main" id="{9C499177-D372-4765-BD67-D3050B382107}"/>
               </a:ext>
             </a:extLst>
           </p:cNvPr>
@@ -4551,7 +4551,7 @@
           <p:cNvPr id="6" name="">
             <a:extLst xmlns:a="http://schemas.openxmlformats.org/drawingml/2006/main">
               <a:ext uri="{FF2B5EF4-FFF2-40B4-BE49-F238E27FC236}">
-                <a16:creationId xmlns:a16="http://schemas.microsoft.com/office/drawing/2014/main" id="{3D7B09C9-0D78-4205-92D8-1A7D3BD0288A}"/>
+                <a16:creationId xmlns:a16="http://schemas.microsoft.com/office/drawing/2014/main" id="{00328914-47EE-44E0-AD99-86A4822F643A}"/>
               </a:ext>
             </a:extLst>
           </p:cNvPr>
@@ -4707,7 +4707,7 @@
           <p:cNvPr id="7" name="">
             <a:extLst xmlns:a="http://schemas.openxmlformats.org/drawingml/2006/main">
               <a:ext uri="{FF2B5EF4-FFF2-40B4-BE49-F238E27FC236}">
-                <a16:creationId xmlns:a16="http://schemas.microsoft.com/office/drawing/2014/main" id="{16CAF14E-DAC6-4459-9393-EE2DCB95997E}"/>
+                <a16:creationId xmlns:a16="http://schemas.microsoft.com/office/drawing/2014/main" id="{3FB4035A-66FE-49B5-89E0-B63FF3EBC427}"/>
               </a:ext>
             </a:extLst>
           </p:cNvPr>
@@ -4863,7 +4863,7 @@
           <p:cNvPr id="8" name="">
             <a:extLst xmlns:a="http://schemas.openxmlformats.org/drawingml/2006/main">
               <a:ext uri="{FF2B5EF4-FFF2-40B4-BE49-F238E27FC236}">
-                <a16:creationId xmlns:a16="http://schemas.microsoft.com/office/drawing/2014/main" id="{F59CD43D-50AB-41D9-A022-48E9308A577A}"/>
+                <a16:creationId xmlns:a16="http://schemas.microsoft.com/office/drawing/2014/main" id="{FF80B507-A14C-4DDC-8BA7-546838A22CBD}"/>
               </a:ext>
             </a:extLst>
           </p:cNvPr>
@@ -5014,10 +5014,166 @@
           </a:p>
         </p:txBody>
       </p:sp>
+      <p:sp>
+        <p:nvSpPr>
+          <p:cNvPr id="9" name="">
+            <a:extLst xmlns:a="http://schemas.openxmlformats.org/drawingml/2006/main">
+              <a:ext uri="{FF2B5EF4-FFF2-40B4-BE49-F238E27FC236}">
+                <a16:creationId xmlns:a16="http://schemas.microsoft.com/office/drawing/2014/main" id="{45D65CE0-4A83-461A-93CF-705D45D57B8B}"/>
+              </a:ext>
+            </a:extLst>
+          </p:cNvPr>
+          <p:cNvSpPr>
+            <a:spLocks xmlns:a="http://schemas.openxmlformats.org/drawingml/2006/main" noGrp="1"/>
+          </p:cNvSpPr>
+          <p:nvPr/>
+        </p:nvSpPr>
+        <p:spPr>
+          <a:xfrm xmlns:a="http://schemas.openxmlformats.org/drawingml/2006/main">
+            <a:off x="714375" y="5810250"/>
+            <a:ext cx="4762500" cy="333375"/>
+          </a:xfrm>
+          <a:prstGeom xmlns:a="http://schemas.openxmlformats.org/drawingml/2006/main" prst="rect">
+            <a:avLst/>
+          </a:prstGeom>
+          <a:noFill xmlns:a="http://schemas.openxmlformats.org/drawingml/2006/main"/>
+          <a:ln xmlns:a="http://schemas.openxmlformats.org/drawingml/2006/main" w="0">
+            <a:noFill/>
+          </a:ln>
+        </p:spPr>
+        <p:txBody>
+          <a:bodyPr xmlns:a="http://schemas.openxmlformats.org/drawingml/2006/main"/>
+          <a:lstStyle xmlns:a="http://schemas.openxmlformats.org/drawingml/2006/main">
+            <a:defPPr>
+              <a:defRPr sz="1650" b="0">
+                <a:solidFill>
+                  <a:srgbClr val="526771"/>
+                </a:solidFill>
+                <a:latin typeface="Arial"/>
+                <a:ea typeface="Arial"/>
+                <a:cs typeface="Arial"/>
+              </a:defRPr>
+            </a:defPPr>
+            <a:lvl1pPr>
+              <a:defRPr sz="1650" b="0">
+                <a:solidFill>
+                  <a:srgbClr val="526771"/>
+                </a:solidFill>
+                <a:latin typeface="Arial"/>
+                <a:ea typeface="Arial"/>
+                <a:cs typeface="Arial"/>
+              </a:defRPr>
+            </a:lvl1pPr>
+            <a:lvl2pPr>
+              <a:defRPr sz="1650" b="0">
+                <a:solidFill>
+                  <a:srgbClr val="526771"/>
+                </a:solidFill>
+                <a:latin typeface="Arial"/>
+                <a:ea typeface="Arial"/>
+                <a:cs typeface="Arial"/>
+              </a:defRPr>
+            </a:lvl2pPr>
+            <a:lvl3pPr>
+              <a:defRPr sz="1650" b="0">
+                <a:solidFill>
+                  <a:srgbClr val="526771"/>
+                </a:solidFill>
+                <a:latin typeface="Arial"/>
+                <a:ea typeface="Arial"/>
+                <a:cs typeface="Arial"/>
+              </a:defRPr>
+            </a:lvl3pPr>
+            <a:lvl4pPr>
+              <a:defRPr sz="1650" b="0">
+                <a:solidFill>
+                  <a:srgbClr val="526771"/>
+                </a:solidFill>
+                <a:latin typeface="Arial"/>
+                <a:ea typeface="Arial"/>
+                <a:cs typeface="Arial"/>
+              </a:defRPr>
+            </a:lvl4pPr>
+            <a:lvl5pPr>
+              <a:defRPr sz="1650" b="0">
+                <a:solidFill>
+                  <a:srgbClr val="526771"/>
+                </a:solidFill>
+                <a:latin typeface="Arial"/>
+                <a:ea typeface="Arial"/>
+                <a:cs typeface="Arial"/>
+              </a:defRPr>
+            </a:lvl5pPr>
+            <a:lvl6pPr>
+              <a:defRPr sz="1650" b="0">
+                <a:solidFill>
+                  <a:srgbClr val="526771"/>
+                </a:solidFill>
+                <a:latin typeface="Arial"/>
+                <a:ea typeface="Arial"/>
+                <a:cs typeface="Arial"/>
+              </a:defRPr>
+            </a:lvl6pPr>
+            <a:lvl7pPr>
+              <a:defRPr sz="1650" b="0">
+                <a:solidFill>
+                  <a:srgbClr val="526771"/>
+                </a:solidFill>
+                <a:latin typeface="Arial"/>
+                <a:ea typeface="Arial"/>
+                <a:cs typeface="Arial"/>
+              </a:defRPr>
+            </a:lvl7pPr>
+            <a:lvl8pPr>
+              <a:defRPr sz="1650" b="0">
+                <a:solidFill>
+                  <a:srgbClr val="526771"/>
+                </a:solidFill>
+                <a:latin typeface="Arial"/>
+                <a:ea typeface="Arial"/>
+                <a:cs typeface="Arial"/>
+              </a:defRPr>
+            </a:lvl8pPr>
+            <a:lvl9pPr>
+              <a:defRPr sz="1650" b="0">
+                <a:solidFill>
+                  <a:srgbClr val="526771"/>
+                </a:solidFill>
+                <a:latin typeface="Arial"/>
+                <a:ea typeface="Arial"/>
+                <a:cs typeface="Arial"/>
+              </a:defRPr>
+            </a:lvl9pPr>
+          </a:lstStyle>
+          <a:p xmlns:a="http://schemas.openxmlformats.org/drawingml/2006/main">
+            <a:pPr>
+              <a:defRPr sz="1650" b="0">
+                <a:solidFill>
+                  <a:srgbClr val="526771"/>
+                </a:solidFill>
+                <a:latin typeface="Arial"/>
+                <a:ea typeface="Arial"/>
+                <a:cs typeface="Arial"/>
+              </a:defRPr>
+            </a:pPr>
+            <a:r>
+              <a:rPr sz="1650" b="0">
+                <a:solidFill>
+                  <a:srgbClr val="526771"/>
+                </a:solidFill>
+                <a:latin typeface="Arial"/>
+                <a:ea typeface="Arial"/>
+                <a:cs typeface="Arial"/>
+              </a:rPr>
+              <a:t>Author: Dr. Geoff Cheng</a:t>
+            </a:r>
+          </a:p>
+        </p:txBody>
+      </p:sp>
     </p:spTree>
     <p:extLst>
       <p:ext uri="{BB962C8B-B14F-4D97-AF65-F5344CB8AC3E}">
-        <p14:creationId xmlns:p14="http://schemas.microsoft.com/office/powerpoint/2010/main" val="1759581918"/>
+        <p14:creationId xmlns:p14="http://schemas.microsoft.com/office/powerpoint/2010/main" val="1174722650"/>
       </p:ext>
     </p:extLst>
   </p:cSld>
@@ -5048,7 +5204,7 @@
           <p:cNvPr id="22" name="">
             <a:extLst xmlns:a="http://schemas.openxmlformats.org/drawingml/2006/main">
               <a:ext uri="{FF2B5EF4-FFF2-40B4-BE49-F238E27FC236}">
-                <a16:creationId xmlns:a16="http://schemas.microsoft.com/office/drawing/2014/main" id="{ECA53BF9-8D92-4929-A717-395589A6A19F}"/>
+                <a16:creationId xmlns:a16="http://schemas.microsoft.com/office/drawing/2014/main" id="{DE415405-93EA-40E4-8E4B-8D9F0B6610CA}"/>
               </a:ext>
             </a:extLst>
           </p:cNvPr>
@@ -5080,7 +5236,7 @@
           <p:cNvPr id="18" name="">
             <a:extLst xmlns:a="http://schemas.openxmlformats.org/drawingml/2006/main">
               <a:ext uri="{FF2B5EF4-FFF2-40B4-BE49-F238E27FC236}">
-                <a16:creationId xmlns:a16="http://schemas.microsoft.com/office/drawing/2014/main" id="{36BB6BEC-51D4-4948-9004-748CA3DB2181}"/>
+                <a16:creationId xmlns:a16="http://schemas.microsoft.com/office/drawing/2014/main" id="{ECF774FB-B99E-48AA-96D7-B6A5F2F41783}"/>
               </a:ext>
             </a:extLst>
           </p:cNvPr>
@@ -5114,7 +5270,7 @@
           <p:cNvPr id="17" name="">
             <a:extLst xmlns:a="http://schemas.openxmlformats.org/drawingml/2006/main">
               <a:ext uri="{FF2B5EF4-FFF2-40B4-BE49-F238E27FC236}">
-                <a16:creationId xmlns:a16="http://schemas.microsoft.com/office/drawing/2014/main" id="{9897A66D-82FB-4340-8D61-22443A1A4838}"/>
+                <a16:creationId xmlns:a16="http://schemas.microsoft.com/office/drawing/2014/main" id="{E821D700-997D-4071-B5E4-3DA13900B772}"/>
               </a:ext>
             </a:extLst>
           </p:cNvPr>
@@ -5146,7 +5302,7 @@
           <p:cNvPr id="16" name="">
             <a:extLst xmlns:a="http://schemas.openxmlformats.org/drawingml/2006/main">
               <a:ext uri="{FF2B5EF4-FFF2-40B4-BE49-F238E27FC236}">
-                <a16:creationId xmlns:a16="http://schemas.microsoft.com/office/drawing/2014/main" id="{7789D711-E23F-4E2D-8633-B7B11A67E314}"/>
+                <a16:creationId xmlns:a16="http://schemas.microsoft.com/office/drawing/2014/main" id="{F0A5DE8D-3B54-46A5-8380-43EE08C20286}"/>
               </a:ext>
             </a:extLst>
           </p:cNvPr>
@@ -5178,7 +5334,7 @@
           <p:cNvPr id="26" name="">
             <a:extLst xmlns:a="http://schemas.openxmlformats.org/drawingml/2006/main">
               <a:ext uri="{FF2B5EF4-FFF2-40B4-BE49-F238E27FC236}">
-                <a16:creationId xmlns:a16="http://schemas.microsoft.com/office/drawing/2014/main" id="{DE262BE3-1972-4ACD-99A8-153961BF3789}"/>
+                <a16:creationId xmlns:a16="http://schemas.microsoft.com/office/drawing/2014/main" id="{928B902D-F8C8-4EA6-81AC-5C1D925B03FD}"/>
               </a:ext>
             </a:extLst>
           </p:cNvPr>
@@ -5334,7 +5490,7 @@
           <p:cNvPr id="2" name="">
             <a:extLst xmlns:a="http://schemas.openxmlformats.org/drawingml/2006/main">
               <a:ext uri="{FF2B5EF4-FFF2-40B4-BE49-F238E27FC236}">
-                <a16:creationId xmlns:a16="http://schemas.microsoft.com/office/drawing/2014/main" id="{D1C2406C-097D-442D-AF99-4AD1DF2D4EE3}"/>
+                <a16:creationId xmlns:a16="http://schemas.microsoft.com/office/drawing/2014/main" id="{00558E7C-D999-4E4C-9D9A-3BA7D03ED8EB}"/>
               </a:ext>
             </a:extLst>
           </p:cNvPr>
@@ -5490,7 +5646,7 @@
           <p:cNvPr id="3" name="">
             <a:extLst xmlns:a="http://schemas.openxmlformats.org/drawingml/2006/main">
               <a:ext uri="{FF2B5EF4-FFF2-40B4-BE49-F238E27FC236}">
-                <a16:creationId xmlns:a16="http://schemas.microsoft.com/office/drawing/2014/main" id="{D38FAE97-96DC-46D2-B1EF-5B9379275078}"/>
+                <a16:creationId xmlns:a16="http://schemas.microsoft.com/office/drawing/2014/main" id="{3EBC443E-32ED-4D01-B696-924B560A399E}"/>
               </a:ext>
             </a:extLst>
           </p:cNvPr>
@@ -5646,7 +5802,7 @@
           <p:cNvPr id="4" name="">
             <a:extLst xmlns:a="http://schemas.openxmlformats.org/drawingml/2006/main">
               <a:ext uri="{FF2B5EF4-FFF2-40B4-BE49-F238E27FC236}">
-                <a16:creationId xmlns:a16="http://schemas.microsoft.com/office/drawing/2014/main" id="{B79D90A5-B9FB-4510-BDA5-6445FAEE0B47}"/>
+                <a16:creationId xmlns:a16="http://schemas.microsoft.com/office/drawing/2014/main" id="{29E585B1-AD68-4666-AD7D-9DE993CF881A}"/>
               </a:ext>
             </a:extLst>
           </p:cNvPr>
@@ -5802,7 +5958,7 @@
           <p:cNvPr id="5" name="">
             <a:extLst xmlns:a="http://schemas.openxmlformats.org/drawingml/2006/main">
               <a:ext uri="{FF2B5EF4-FFF2-40B4-BE49-F238E27FC236}">
-                <a16:creationId xmlns:a16="http://schemas.microsoft.com/office/drawing/2014/main" id="{09B562AC-2D48-4C7B-B262-73ACB9B08221}"/>
+                <a16:creationId xmlns:a16="http://schemas.microsoft.com/office/drawing/2014/main" id="{92B78800-0BA6-4A99-A5F5-FD0A5777DA4C}"/>
               </a:ext>
             </a:extLst>
           </p:cNvPr>
@@ -5958,7 +6114,7 @@
           <p:cNvPr id="6" name="">
             <a:extLst xmlns:a="http://schemas.openxmlformats.org/drawingml/2006/main">
               <a:ext uri="{FF2B5EF4-FFF2-40B4-BE49-F238E27FC236}">
-                <a16:creationId xmlns:a16="http://schemas.microsoft.com/office/drawing/2014/main" id="{7A9C516B-9F84-40F2-A4DC-38798E192D95}"/>
+                <a16:creationId xmlns:a16="http://schemas.microsoft.com/office/drawing/2014/main" id="{7E99357B-06AC-4C02-8797-8215FC9766F4}"/>
               </a:ext>
             </a:extLst>
           </p:cNvPr>
@@ -5990,7 +6146,7 @@
           <p:cNvPr id="7" name="">
             <a:extLst xmlns:a="http://schemas.openxmlformats.org/drawingml/2006/main">
               <a:ext uri="{FF2B5EF4-FFF2-40B4-BE49-F238E27FC236}">
-                <a16:creationId xmlns:a16="http://schemas.microsoft.com/office/drawing/2014/main" id="{7EB23403-AEA5-4619-B5E9-B9789DC53316}"/>
+                <a16:creationId xmlns:a16="http://schemas.microsoft.com/office/drawing/2014/main" id="{71A383B0-2B4E-44AF-9B93-436841A5C5F1}"/>
               </a:ext>
             </a:extLst>
           </p:cNvPr>
@@ -6169,7 +6325,7 @@
           <p:cNvPr id="8" name="">
             <a:extLst xmlns:a="http://schemas.openxmlformats.org/drawingml/2006/main">
               <a:ext uri="{FF2B5EF4-FFF2-40B4-BE49-F238E27FC236}">
-                <a16:creationId xmlns:a16="http://schemas.microsoft.com/office/drawing/2014/main" id="{DC92F593-AA1E-454B-94D6-8F7A31C5BC18}"/>
+                <a16:creationId xmlns:a16="http://schemas.microsoft.com/office/drawing/2014/main" id="{63DAADB6-3E0F-45D0-ADD1-5742A90E8B13}"/>
               </a:ext>
             </a:extLst>
           </p:cNvPr>
@@ -6201,7 +6357,7 @@
           <p:cNvPr id="9" name="">
             <a:extLst xmlns:a="http://schemas.openxmlformats.org/drawingml/2006/main">
               <a:ext uri="{FF2B5EF4-FFF2-40B4-BE49-F238E27FC236}">
-                <a16:creationId xmlns:a16="http://schemas.microsoft.com/office/drawing/2014/main" id="{FE7B0F7D-8E84-4D41-B637-CF28E35320C1}"/>
+                <a16:creationId xmlns:a16="http://schemas.microsoft.com/office/drawing/2014/main" id="{5C81C1AC-E353-445C-98F5-973B5157C050}"/>
               </a:ext>
             </a:extLst>
           </p:cNvPr>
@@ -6380,7 +6536,7 @@
           <p:cNvPr id="10" name="">
             <a:extLst xmlns:a="http://schemas.openxmlformats.org/drawingml/2006/main">
               <a:ext uri="{FF2B5EF4-FFF2-40B4-BE49-F238E27FC236}">
-                <a16:creationId xmlns:a16="http://schemas.microsoft.com/office/drawing/2014/main" id="{3A1999F1-FC59-4FC7-9400-196907B86737}"/>
+                <a16:creationId xmlns:a16="http://schemas.microsoft.com/office/drawing/2014/main" id="{61C3E697-6B9C-4F04-A186-A13479C7B2A2}"/>
               </a:ext>
             </a:extLst>
           </p:cNvPr>
@@ -6412,7 +6568,7 @@
           <p:cNvPr id="11" name="">
             <a:extLst xmlns:a="http://schemas.openxmlformats.org/drawingml/2006/main">
               <a:ext uri="{FF2B5EF4-FFF2-40B4-BE49-F238E27FC236}">
-                <a16:creationId xmlns:a16="http://schemas.microsoft.com/office/drawing/2014/main" id="{18162CE4-CFB8-45F3-A1E8-386A9ACE4874}"/>
+                <a16:creationId xmlns:a16="http://schemas.microsoft.com/office/drawing/2014/main" id="{6EF6A1D2-2F38-40B0-91E0-20DC62EFEF53}"/>
               </a:ext>
             </a:extLst>
           </p:cNvPr>
@@ -6591,7 +6747,7 @@
           <p:cNvPr id="12" name="">
             <a:extLst xmlns:a="http://schemas.openxmlformats.org/drawingml/2006/main">
               <a:ext uri="{FF2B5EF4-FFF2-40B4-BE49-F238E27FC236}">
-                <a16:creationId xmlns:a16="http://schemas.microsoft.com/office/drawing/2014/main" id="{7B903608-D048-42C8-AB2B-3D9B2A8ACD69}"/>
+                <a16:creationId xmlns:a16="http://schemas.microsoft.com/office/drawing/2014/main" id="{91284246-32A8-45E0-A3A4-7FDD6C4F9854}"/>
               </a:ext>
             </a:extLst>
           </p:cNvPr>
@@ -6623,7 +6779,7 @@
           <p:cNvPr id="13" name="">
             <a:extLst xmlns:a="http://schemas.openxmlformats.org/drawingml/2006/main">
               <a:ext uri="{FF2B5EF4-FFF2-40B4-BE49-F238E27FC236}">
-                <a16:creationId xmlns:a16="http://schemas.microsoft.com/office/drawing/2014/main" id="{0DA70CCB-6B7D-4B88-8A40-5205EE045011}"/>
+                <a16:creationId xmlns:a16="http://schemas.microsoft.com/office/drawing/2014/main" id="{5C54CC9C-064E-4602-9DEF-F25104D6E219}"/>
               </a:ext>
             </a:extLst>
           </p:cNvPr>
@@ -6802,7 +6958,7 @@
           <p:cNvPr id="14" name="">
             <a:extLst xmlns:a="http://schemas.openxmlformats.org/drawingml/2006/main">
               <a:ext uri="{FF2B5EF4-FFF2-40B4-BE49-F238E27FC236}">
-                <a16:creationId xmlns:a16="http://schemas.microsoft.com/office/drawing/2014/main" id="{BEC9E895-19E0-46DD-9F83-9F42B746CF11}"/>
+                <a16:creationId xmlns:a16="http://schemas.microsoft.com/office/drawing/2014/main" id="{54162254-7D70-433E-87B8-B120A9A825F4}"/>
               </a:ext>
             </a:extLst>
           </p:cNvPr>
@@ -6834,7 +6990,7 @@
           <p:cNvPr id="15" name="">
             <a:extLst xmlns:a="http://schemas.openxmlformats.org/drawingml/2006/main">
               <a:ext uri="{FF2B5EF4-FFF2-40B4-BE49-F238E27FC236}">
-                <a16:creationId xmlns:a16="http://schemas.microsoft.com/office/drawing/2014/main" id="{CDA81AB5-F6D3-4147-805E-62F0C45FBA5E}"/>
+                <a16:creationId xmlns:a16="http://schemas.microsoft.com/office/drawing/2014/main" id="{938F6991-73A9-4ED0-BC17-2EB2176462E5}"/>
               </a:ext>
             </a:extLst>
           </p:cNvPr>
@@ -7013,7 +7169,7 @@
           <p:cNvPr id="19" name="">
             <a:extLst xmlns:a="http://schemas.openxmlformats.org/drawingml/2006/main">
               <a:ext uri="{FF2B5EF4-FFF2-40B4-BE49-F238E27FC236}">
-                <a16:creationId xmlns:a16="http://schemas.microsoft.com/office/drawing/2014/main" id="{1C07AD83-05D5-47B9-BD36-8EB0DC0600C9}"/>
+                <a16:creationId xmlns:a16="http://schemas.microsoft.com/office/drawing/2014/main" id="{14C9B882-D4FF-4C8F-836E-5E3F4E7E367B}"/>
               </a:ext>
             </a:extLst>
           </p:cNvPr>
@@ -7041,7 +7197,7 @@
           <p:cNvPr id="20" name="">
             <a:extLst xmlns:a="http://schemas.openxmlformats.org/drawingml/2006/main">
               <a:ext uri="{FF2B5EF4-FFF2-40B4-BE49-F238E27FC236}">
-                <a16:creationId xmlns:a16="http://schemas.microsoft.com/office/drawing/2014/main" id="{ABCC9732-68CE-4283-8AA4-BC542D99A04F}"/>
+                <a16:creationId xmlns:a16="http://schemas.microsoft.com/office/drawing/2014/main" id="{A4CF9F7B-45CF-4E1B-B8CC-158E47B41494}"/>
               </a:ext>
             </a:extLst>
           </p:cNvPr>
@@ -7069,7 +7225,7 @@
           <p:cNvPr id="21" name="">
             <a:extLst xmlns:a="http://schemas.openxmlformats.org/drawingml/2006/main">
               <a:ext uri="{FF2B5EF4-FFF2-40B4-BE49-F238E27FC236}">
-                <a16:creationId xmlns:a16="http://schemas.microsoft.com/office/drawing/2014/main" id="{15C6FB60-EBC2-4769-ADA9-52CCC7F33D80}"/>
+                <a16:creationId xmlns:a16="http://schemas.microsoft.com/office/drawing/2014/main" id="{ADD826BB-4F11-463B-BAD1-D7E35B9DEB27}"/>
               </a:ext>
             </a:extLst>
           </p:cNvPr>
@@ -7098,7 +7254,7 @@
           <p:cNvPr id="23" name="">
             <a:extLst xmlns:a="http://schemas.openxmlformats.org/drawingml/2006/main">
               <a:ext uri="{FF2B5EF4-FFF2-40B4-BE49-F238E27FC236}">
-                <a16:creationId xmlns:a16="http://schemas.microsoft.com/office/drawing/2014/main" id="{BFB92602-D7AC-4B19-980D-C396878DC938}"/>
+                <a16:creationId xmlns:a16="http://schemas.microsoft.com/office/drawing/2014/main" id="{480A32D3-CEE9-44C2-B6E4-58596DE929BD}"/>
               </a:ext>
             </a:extLst>
           </p:cNvPr>
@@ -7254,7 +7410,7 @@
           <p:cNvPr id="24" name="">
             <a:extLst xmlns:a="http://schemas.openxmlformats.org/drawingml/2006/main">
               <a:ext uri="{FF2B5EF4-FFF2-40B4-BE49-F238E27FC236}">
-                <a16:creationId xmlns:a16="http://schemas.microsoft.com/office/drawing/2014/main" id="{08A7AA2F-9EB4-4C05-8AC2-8550FAD65522}"/>
+                <a16:creationId xmlns:a16="http://schemas.microsoft.com/office/drawing/2014/main" id="{98D5D06B-B886-4C94-BE57-A66C84BD828D}"/>
               </a:ext>
             </a:extLst>
           </p:cNvPr>
@@ -7410,7 +7566,7 @@
           <p:cNvPr id="25" name="">
             <a:extLst xmlns:a="http://schemas.openxmlformats.org/drawingml/2006/main">
               <a:ext uri="{FF2B5EF4-FFF2-40B4-BE49-F238E27FC236}">
-                <a16:creationId xmlns:a16="http://schemas.microsoft.com/office/drawing/2014/main" id="{AF2028C5-2AAD-42CE-9629-9B6FABE255E3}"/>
+                <a16:creationId xmlns:a16="http://schemas.microsoft.com/office/drawing/2014/main" id="{7ABA53D5-8241-430A-BA34-654AC8BD704E}"/>
               </a:ext>
             </a:extLst>
           </p:cNvPr>
@@ -7587,7 +7743,7 @@
     </p:spTree>
     <p:extLst>
       <p:ext uri="{BB962C8B-B14F-4D97-AF65-F5344CB8AC3E}">
-        <p14:creationId xmlns:p14="http://schemas.microsoft.com/office/powerpoint/2010/main" val="1779481793"/>
+        <p14:creationId xmlns:p14="http://schemas.microsoft.com/office/powerpoint/2010/main" val="687191310"/>
       </p:ext>
     </p:extLst>
   </p:cSld>
@@ -7618,7 +7774,7 @@
           <p:cNvPr id="5" name="">
             <a:extLst xmlns:a="http://schemas.openxmlformats.org/drawingml/2006/main">
               <a:ext uri="{FF2B5EF4-FFF2-40B4-BE49-F238E27FC236}">
-                <a16:creationId xmlns:a16="http://schemas.microsoft.com/office/drawing/2014/main" id="{F7E6B8CD-361F-4306-B19A-40AACF22944D}"/>
+                <a16:creationId xmlns:a16="http://schemas.microsoft.com/office/drawing/2014/main" id="{C6EB2872-1218-499E-9DD9-99ED96F81751}"/>
               </a:ext>
             </a:extLst>
           </p:cNvPr>
@@ -7774,7 +7930,7 @@
           <p:cNvPr id="2" name="">
             <a:extLst xmlns:a="http://schemas.openxmlformats.org/drawingml/2006/main">
               <a:ext uri="{FF2B5EF4-FFF2-40B4-BE49-F238E27FC236}">
-                <a16:creationId xmlns:a16="http://schemas.microsoft.com/office/drawing/2014/main" id="{7C3D60A1-A79F-450F-B3CE-94671DF096A4}"/>
+                <a16:creationId xmlns:a16="http://schemas.microsoft.com/office/drawing/2014/main" id="{E47D4F20-2FB0-4166-9AB1-467E4F004AEF}"/>
               </a:ext>
             </a:extLst>
           </p:cNvPr>
@@ -7930,7 +8086,7 @@
           <p:cNvPr id="3" name="">
             <a:extLst xmlns:a="http://schemas.openxmlformats.org/drawingml/2006/main">
               <a:ext uri="{FF2B5EF4-FFF2-40B4-BE49-F238E27FC236}">
-                <a16:creationId xmlns:a16="http://schemas.microsoft.com/office/drawing/2014/main" id="{C0CBD4CD-1C44-4E4E-B3EE-33F38DBDB00A}"/>
+                <a16:creationId xmlns:a16="http://schemas.microsoft.com/office/drawing/2014/main" id="{398242DA-62D3-491F-B7C5-9B2295DEC0EB}"/>
               </a:ext>
             </a:extLst>
           </p:cNvPr>
@@ -8086,7 +8242,7 @@
           <p:cNvPr id="4" name="">
             <a:extLst xmlns:a="http://schemas.openxmlformats.org/drawingml/2006/main">
               <a:ext uri="{FF2B5EF4-FFF2-40B4-BE49-F238E27FC236}">
-                <a16:creationId xmlns:a16="http://schemas.microsoft.com/office/drawing/2014/main" id="{E7E0F547-48A1-4033-83B5-2ED00E346187}"/>
+                <a16:creationId xmlns:a16="http://schemas.microsoft.com/office/drawing/2014/main" id="{C279F6A3-9570-404A-BD3C-B0382A1DD619}"/>
               </a:ext>
             </a:extLst>
           </p:cNvPr>
@@ -8710,7 +8866,7 @@
     </p:spTree>
     <p:extLst>
       <p:ext uri="{BB962C8B-B14F-4D97-AF65-F5344CB8AC3E}">
-        <p14:creationId xmlns:p14="http://schemas.microsoft.com/office/powerpoint/2010/main" val="1411876269"/>
+        <p14:creationId xmlns:p14="http://schemas.microsoft.com/office/powerpoint/2010/main" val="1731923986"/>
       </p:ext>
     </p:extLst>
   </p:cSld>
@@ -8741,7 +8897,7 @@
           <p:cNvPr id="14" name="">
             <a:extLst xmlns:a="http://schemas.openxmlformats.org/drawingml/2006/main">
               <a:ext uri="{FF2B5EF4-FFF2-40B4-BE49-F238E27FC236}">
-                <a16:creationId xmlns:a16="http://schemas.microsoft.com/office/drawing/2014/main" id="{82CA0D36-153C-4B4C-9621-58587EAE4393}"/>
+                <a16:creationId xmlns:a16="http://schemas.microsoft.com/office/drawing/2014/main" id="{BB4FABAE-1887-49E7-8E53-5211550E1177}"/>
               </a:ext>
             </a:extLst>
           </p:cNvPr>
@@ -8897,7 +9053,7 @@
           <p:cNvPr id="2" name="">
             <a:extLst xmlns:a="http://schemas.openxmlformats.org/drawingml/2006/main">
               <a:ext uri="{FF2B5EF4-FFF2-40B4-BE49-F238E27FC236}">
-                <a16:creationId xmlns:a16="http://schemas.microsoft.com/office/drawing/2014/main" id="{A865DCD9-E7A7-4E72-BEC9-49627E4F6B75}"/>
+                <a16:creationId xmlns:a16="http://schemas.microsoft.com/office/drawing/2014/main" id="{C1B41AC1-648C-40D3-BC98-C319F4BD8A1C}"/>
               </a:ext>
             </a:extLst>
           </p:cNvPr>
@@ -9053,7 +9209,7 @@
           <p:cNvPr id="3" name="">
             <a:extLst xmlns:a="http://schemas.openxmlformats.org/drawingml/2006/main">
               <a:ext uri="{FF2B5EF4-FFF2-40B4-BE49-F238E27FC236}">
-                <a16:creationId xmlns:a16="http://schemas.microsoft.com/office/drawing/2014/main" id="{A63DE473-5A19-4F3A-97B2-94CAC24A09E5}"/>
+                <a16:creationId xmlns:a16="http://schemas.microsoft.com/office/drawing/2014/main" id="{BB59FFCA-2B8C-4BE2-9B5C-9854DDE8FF54}"/>
               </a:ext>
             </a:extLst>
           </p:cNvPr>
@@ -9209,7 +9365,7 @@
           <p:cNvPr id="4" name="">
             <a:extLst xmlns:a="http://schemas.openxmlformats.org/drawingml/2006/main">
               <a:ext uri="{FF2B5EF4-FFF2-40B4-BE49-F238E27FC236}">
-                <a16:creationId xmlns:a16="http://schemas.microsoft.com/office/drawing/2014/main" id="{C446C189-8CBB-4212-8265-520B4AF8D3B2}"/>
+                <a16:creationId xmlns:a16="http://schemas.microsoft.com/office/drawing/2014/main" id="{933607D6-BCF6-4A86-9D48-2E2038EA8091}"/>
               </a:ext>
             </a:extLst>
           </p:cNvPr>
@@ -9365,7 +9521,7 @@
           <p:cNvPr id="5" name="">
             <a:extLst xmlns:a="http://schemas.openxmlformats.org/drawingml/2006/main">
               <a:ext uri="{FF2B5EF4-FFF2-40B4-BE49-F238E27FC236}">
-                <a16:creationId xmlns:a16="http://schemas.microsoft.com/office/drawing/2014/main" id="{C01A9C95-1371-4095-B2BE-7B03104C6CE4}"/>
+                <a16:creationId xmlns:a16="http://schemas.microsoft.com/office/drawing/2014/main" id="{CA5A1D8D-1731-40F3-869F-313D9CE60D0E}"/>
               </a:ext>
             </a:extLst>
           </p:cNvPr>
@@ -9521,7 +9677,7 @@
           <p:cNvPr id="6" name="">
             <a:extLst xmlns:a="http://schemas.openxmlformats.org/drawingml/2006/main">
               <a:ext uri="{FF2B5EF4-FFF2-40B4-BE49-F238E27FC236}">
-                <a16:creationId xmlns:a16="http://schemas.microsoft.com/office/drawing/2014/main" id="{AF37ADFF-E45B-4F5A-997B-C0512165290E}"/>
+                <a16:creationId xmlns:a16="http://schemas.microsoft.com/office/drawing/2014/main" id="{A7005C14-B47C-427A-8323-37177FC8DC52}"/>
               </a:ext>
             </a:extLst>
           </p:cNvPr>
@@ -9700,7 +9856,7 @@
           <p:cNvPr id="7" name="">
             <a:extLst xmlns:a="http://schemas.openxmlformats.org/drawingml/2006/main">
               <a:ext uri="{FF2B5EF4-FFF2-40B4-BE49-F238E27FC236}">
-                <a16:creationId xmlns:a16="http://schemas.microsoft.com/office/drawing/2014/main" id="{708E1652-3249-4C80-91D5-A7792BDD1EEB}"/>
+                <a16:creationId xmlns:a16="http://schemas.microsoft.com/office/drawing/2014/main" id="{10CEEB1C-C548-4A6F-B7E8-8365418E13A3}"/>
               </a:ext>
             </a:extLst>
           </p:cNvPr>
@@ -9879,7 +10035,7 @@
           <p:cNvPr id="8" name="">
             <a:extLst xmlns:a="http://schemas.openxmlformats.org/drawingml/2006/main">
               <a:ext uri="{FF2B5EF4-FFF2-40B4-BE49-F238E27FC236}">
-                <a16:creationId xmlns:a16="http://schemas.microsoft.com/office/drawing/2014/main" id="{D64908C2-C55A-4B51-9D27-DC9BCFBD0ECE}"/>
+                <a16:creationId xmlns:a16="http://schemas.microsoft.com/office/drawing/2014/main" id="{A36286E4-BF0A-49D2-9690-314020CD3067}"/>
               </a:ext>
             </a:extLst>
           </p:cNvPr>
@@ -10058,7 +10214,7 @@
           <p:cNvPr id="9" name="">
             <a:extLst xmlns:a="http://schemas.openxmlformats.org/drawingml/2006/main">
               <a:ext uri="{FF2B5EF4-FFF2-40B4-BE49-F238E27FC236}">
-                <a16:creationId xmlns:a16="http://schemas.microsoft.com/office/drawing/2014/main" id="{D81997C9-1047-4C70-839A-0C21156701CF}"/>
+                <a16:creationId xmlns:a16="http://schemas.microsoft.com/office/drawing/2014/main" id="{F534A13D-7B2B-4E53-AD89-776CD57E273E}"/>
               </a:ext>
             </a:extLst>
           </p:cNvPr>
@@ -10214,7 +10370,7 @@
           <p:cNvPr id="10" name="">
             <a:extLst xmlns:a="http://schemas.openxmlformats.org/drawingml/2006/main">
               <a:ext uri="{FF2B5EF4-FFF2-40B4-BE49-F238E27FC236}">
-                <a16:creationId xmlns:a16="http://schemas.microsoft.com/office/drawing/2014/main" id="{E09C2EC4-5264-453E-B331-CF7E8F1DC328}"/>
+                <a16:creationId xmlns:a16="http://schemas.microsoft.com/office/drawing/2014/main" id="{4CFC31F0-7E00-4068-819C-710D50963CF8}"/>
               </a:ext>
             </a:extLst>
           </p:cNvPr>
@@ -10370,7 +10526,7 @@
           <p:cNvPr id="11" name="">
             <a:extLst xmlns:a="http://schemas.openxmlformats.org/drawingml/2006/main">
               <a:ext uri="{FF2B5EF4-FFF2-40B4-BE49-F238E27FC236}">
-                <a16:creationId xmlns:a16="http://schemas.microsoft.com/office/drawing/2014/main" id="{D7BA17A1-035E-4928-92D4-A158F9B97A2D}"/>
+                <a16:creationId xmlns:a16="http://schemas.microsoft.com/office/drawing/2014/main" id="{4A445611-B54C-4790-94E3-601FF4256AA1}"/>
               </a:ext>
             </a:extLst>
           </p:cNvPr>
@@ -10526,7 +10682,7 @@
           <p:cNvPr id="12" name="">
             <a:extLst xmlns:a="http://schemas.openxmlformats.org/drawingml/2006/main">
               <a:ext uri="{FF2B5EF4-FFF2-40B4-BE49-F238E27FC236}">
-                <a16:creationId xmlns:a16="http://schemas.microsoft.com/office/drawing/2014/main" id="{1DDD3202-5BCA-402A-AB76-F85F50D22A1E}"/>
+                <a16:creationId xmlns:a16="http://schemas.microsoft.com/office/drawing/2014/main" id="{9790F3D5-9A3E-4A54-BA10-70E0AF878778}"/>
               </a:ext>
             </a:extLst>
           </p:cNvPr>
@@ -10728,7 +10884,7 @@
           <p:cNvPr id="13" name="">
             <a:extLst xmlns:a="http://schemas.openxmlformats.org/drawingml/2006/main">
               <a:ext uri="{FF2B5EF4-FFF2-40B4-BE49-F238E27FC236}">
-                <a16:creationId xmlns:a16="http://schemas.microsoft.com/office/drawing/2014/main" id="{3CE91DE2-D1D1-43AC-B23C-CEFF13D323CC}"/>
+                <a16:creationId xmlns:a16="http://schemas.microsoft.com/office/drawing/2014/main" id="{3E3C3F1E-515E-40F1-86A2-7A81980B1241}"/>
               </a:ext>
             </a:extLst>
           </p:cNvPr>
@@ -10905,7 +11061,7 @@
     </p:spTree>
     <p:extLst>
       <p:ext uri="{BB962C8B-B14F-4D97-AF65-F5344CB8AC3E}">
-        <p14:creationId xmlns:p14="http://schemas.microsoft.com/office/powerpoint/2010/main" val="1902146205"/>
+        <p14:creationId xmlns:p14="http://schemas.microsoft.com/office/powerpoint/2010/main" val="1619009629"/>
       </p:ext>
     </p:extLst>
   </p:cSld>
@@ -10936,7 +11092,7 @@
           <p:cNvPr id="13" name="">
             <a:extLst xmlns:a="http://schemas.openxmlformats.org/drawingml/2006/main">
               <a:ext uri="{FF2B5EF4-FFF2-40B4-BE49-F238E27FC236}">
-                <a16:creationId xmlns:a16="http://schemas.microsoft.com/office/drawing/2014/main" id="{6879EB8C-B63B-4DC7-B5FF-8C8C8EC05534}"/>
+                <a16:creationId xmlns:a16="http://schemas.microsoft.com/office/drawing/2014/main" id="{CBA78F27-3BD7-4059-A3D5-91592D048AC2}"/>
               </a:ext>
             </a:extLst>
           </p:cNvPr>
@@ -11092,7 +11248,7 @@
           <p:cNvPr id="2" name="">
             <a:extLst xmlns:a="http://schemas.openxmlformats.org/drawingml/2006/main">
               <a:ext uri="{FF2B5EF4-FFF2-40B4-BE49-F238E27FC236}">
-                <a16:creationId xmlns:a16="http://schemas.microsoft.com/office/drawing/2014/main" id="{9C7E3E84-AD6E-4BAE-962C-9CDB60D3B157}"/>
+                <a16:creationId xmlns:a16="http://schemas.microsoft.com/office/drawing/2014/main" id="{61AB69BF-3F17-46CF-AD38-EF43424B0549}"/>
               </a:ext>
             </a:extLst>
           </p:cNvPr>
@@ -11248,7 +11404,7 @@
           <p:cNvPr id="3" name="">
             <a:extLst xmlns:a="http://schemas.openxmlformats.org/drawingml/2006/main">
               <a:ext uri="{FF2B5EF4-FFF2-40B4-BE49-F238E27FC236}">
-                <a16:creationId xmlns:a16="http://schemas.microsoft.com/office/drawing/2014/main" id="{637F1340-9F8C-47EE-96D2-B1CD1CF0C7B1}"/>
+                <a16:creationId xmlns:a16="http://schemas.microsoft.com/office/drawing/2014/main" id="{61960BCA-9A3E-4C94-96E6-1ED042DCBF91}"/>
               </a:ext>
             </a:extLst>
           </p:cNvPr>
@@ -11404,7 +11560,7 @@
           <p:cNvPr id="4" name="">
             <a:extLst xmlns:a="http://schemas.openxmlformats.org/drawingml/2006/main">
               <a:ext uri="{FF2B5EF4-FFF2-40B4-BE49-F238E27FC236}">
-                <a16:creationId xmlns:a16="http://schemas.microsoft.com/office/drawing/2014/main" id="{3F210834-E812-44B6-8D94-BD043E99A2CA}"/>
+                <a16:creationId xmlns:a16="http://schemas.microsoft.com/office/drawing/2014/main" id="{36E08AED-1AAC-45C9-B767-7C2C35C788E5}"/>
               </a:ext>
             </a:extLst>
           </p:cNvPr>
@@ -11560,7 +11716,7 @@
           <p:cNvPr id="5" name="">
             <a:extLst xmlns:a="http://schemas.openxmlformats.org/drawingml/2006/main">
               <a:ext uri="{FF2B5EF4-FFF2-40B4-BE49-F238E27FC236}">
-                <a16:creationId xmlns:a16="http://schemas.microsoft.com/office/drawing/2014/main" id="{AEC5D6D2-9424-4CA2-AFC8-9EE54F5797F0}"/>
+                <a16:creationId xmlns:a16="http://schemas.microsoft.com/office/drawing/2014/main" id="{09BE0BAE-92CE-44AE-930C-1B4AA1428D35}"/>
               </a:ext>
             </a:extLst>
           </p:cNvPr>
@@ -11716,7 +11872,7 @@
           <p:cNvPr id="6" name="">
             <a:extLst xmlns:a="http://schemas.openxmlformats.org/drawingml/2006/main">
               <a:ext uri="{FF2B5EF4-FFF2-40B4-BE49-F238E27FC236}">
-                <a16:creationId xmlns:a16="http://schemas.microsoft.com/office/drawing/2014/main" id="{12BB192E-7D9C-4AF7-A733-2443AEBB3429}"/>
+                <a16:creationId xmlns:a16="http://schemas.microsoft.com/office/drawing/2014/main" id="{4D1A8C5A-77DD-4CF7-9872-6AF6696307F4}"/>
               </a:ext>
             </a:extLst>
           </p:cNvPr>
@@ -11918,7 +12074,7 @@
           <p:cNvPr id="7" name="">
             <a:extLst xmlns:a="http://schemas.openxmlformats.org/drawingml/2006/main">
               <a:ext uri="{FF2B5EF4-FFF2-40B4-BE49-F238E27FC236}">
-                <a16:creationId xmlns:a16="http://schemas.microsoft.com/office/drawing/2014/main" id="{15761226-F033-49BB-BE0D-A8AE76B5F16E}"/>
+                <a16:creationId xmlns:a16="http://schemas.microsoft.com/office/drawing/2014/main" id="{70CDDDEC-C989-49C0-AA35-E32F8F63E1AA}"/>
               </a:ext>
             </a:extLst>
           </p:cNvPr>
@@ -12074,7 +12230,7 @@
           <p:cNvPr id="8" name="">
             <a:extLst xmlns:a="http://schemas.openxmlformats.org/drawingml/2006/main">
               <a:ext uri="{FF2B5EF4-FFF2-40B4-BE49-F238E27FC236}">
-                <a16:creationId xmlns:a16="http://schemas.microsoft.com/office/drawing/2014/main" id="{6CBD31EF-03BB-4ED9-8431-7A5252FE02B6}"/>
+                <a16:creationId xmlns:a16="http://schemas.microsoft.com/office/drawing/2014/main" id="{8D7E21E5-1564-4B87-8674-7AD9B9563946}"/>
               </a:ext>
             </a:extLst>
           </p:cNvPr>
@@ -12276,7 +12432,7 @@
           <p:cNvPr id="9" name="">
             <a:extLst xmlns:a="http://schemas.openxmlformats.org/drawingml/2006/main">
               <a:ext uri="{FF2B5EF4-FFF2-40B4-BE49-F238E27FC236}">
-                <a16:creationId xmlns:a16="http://schemas.microsoft.com/office/drawing/2014/main" id="{B909DC25-93BF-4A89-B671-B3DD479546B0}"/>
+                <a16:creationId xmlns:a16="http://schemas.microsoft.com/office/drawing/2014/main" id="{B5B12CCB-A4F5-4ADD-90E8-4950659742F5}"/>
               </a:ext>
             </a:extLst>
           </p:cNvPr>
@@ -12432,7 +12588,7 @@
           <p:cNvPr id="10" name="">
             <a:extLst xmlns:a="http://schemas.openxmlformats.org/drawingml/2006/main">
               <a:ext uri="{FF2B5EF4-FFF2-40B4-BE49-F238E27FC236}">
-                <a16:creationId xmlns:a16="http://schemas.microsoft.com/office/drawing/2014/main" id="{658A4A82-1500-4AD7-82A5-C42428E99328}"/>
+                <a16:creationId xmlns:a16="http://schemas.microsoft.com/office/drawing/2014/main" id="{A800A1C3-64E5-4F13-98A4-47592B8B72EF}"/>
               </a:ext>
             </a:extLst>
           </p:cNvPr>
@@ -12588,7 +12744,7 @@
           <p:cNvPr id="11" name="">
             <a:extLst xmlns:a="http://schemas.openxmlformats.org/drawingml/2006/main">
               <a:ext uri="{FF2B5EF4-FFF2-40B4-BE49-F238E27FC236}">
-                <a16:creationId xmlns:a16="http://schemas.microsoft.com/office/drawing/2014/main" id="{6E0D65ED-7871-49B3-8E84-6DA153B12C56}"/>
+                <a16:creationId xmlns:a16="http://schemas.microsoft.com/office/drawing/2014/main" id="{6DEB1A4F-6889-4F71-8F4E-A44F0579AB51}"/>
               </a:ext>
             </a:extLst>
           </p:cNvPr>
@@ -12790,7 +12946,7 @@
           <p:cNvPr id="12" name="">
             <a:extLst xmlns:a="http://schemas.openxmlformats.org/drawingml/2006/main">
               <a:ext uri="{FF2B5EF4-FFF2-40B4-BE49-F238E27FC236}">
-                <a16:creationId xmlns:a16="http://schemas.microsoft.com/office/drawing/2014/main" id="{5B7729D5-31E1-4002-A463-ADFA29682797}"/>
+                <a16:creationId xmlns:a16="http://schemas.microsoft.com/office/drawing/2014/main" id="{044DC612-A0FB-4C2B-A9CC-DAE15C94FE9B}"/>
               </a:ext>
             </a:extLst>
           </p:cNvPr>
@@ -12990,7 +13146,7 @@
     </p:spTree>
     <p:extLst>
       <p:ext uri="{BB962C8B-B14F-4D97-AF65-F5344CB8AC3E}">
-        <p14:creationId xmlns:p14="http://schemas.microsoft.com/office/powerpoint/2010/main" val="1230607063"/>
+        <p14:creationId xmlns:p14="http://schemas.microsoft.com/office/powerpoint/2010/main" val="339475750"/>
       </p:ext>
     </p:extLst>
   </p:cSld>

</xml_diff>